<commit_message>
Acrescenta Objetivos e refaz o fecho na versao editada do deck
Parte de apresentacao/2/ciclo2-planejamento.pptx, a versao revisada no
Google Apresentacoes, preservando as medidas e a paleta ajustadas ali.

Novo slide 7, Objetivos: o objetivo geral na faixa superior e os seis
objetivos especificos agrupados em Formalizar, Construir e Validar.

Slide 11, Reformulacao da hipotese: passa a enunciar a hipotese que
sobreviveu aos experimentos e as duas maneiras de falsea-la, no lugar
do par sustentamos/nao sustentamos, que repetia o slide 10. Corpo de
texto na mesma escala dos demais slides.

Co-Authored-By: Claude Opus 5 (1M context) <noreply@anthropic.com>
</commit_message>
<xml_diff>
--- a/apresentacao/2/ciclo2-planejamento.pptx
+++ b/apresentacao/2/ciclo2-planejamento.pptx
@@ -14,6 +14,7 @@
     <p:sldId id="259" r:id="rId8"/>
     <p:sldId id="260" r:id="rId9"/>
     <p:sldId id="261" r:id="rId10"/>
+    <p:sldId id="266" r:id="rId15"/>
     <p:sldId id="262" r:id="rId11"/>
     <p:sldId id="263" r:id="rId12"/>
     <p:sldId id="264" r:id="rId13"/>
@@ -1668,20 +1669,9 @@
           </a:bodyPr>
           <a:lstStyle/>
           <a:p>
-            <a:pPr indent="0" lvl="0" marL="0" rtl="0" algn="l">
-              <a:spcBef>
-                <a:spcPts val="0"/>
-              </a:spcBef>
-              <a:spcAft>
-                <a:spcPts val="0"/>
-              </a:spcAft>
-              <a:buNone/>
-            </a:pPr>
-            <a:r>
-              <a:rPr lang="en-US"/>
-              <a:t>Fecho. O trunfo do trabalho nao e ter usado Planning. E termos medido COMO ele ajuda neste problema, inclusive descobrindo que a resposta nao era a que esperavamos. Se a banca perguntar o que sobrou: declaratividade com efeito medido, e prova de inviabilidade. Se perguntar o que caiu: economia de tempo e exclusividade de capacidade.</a:t>
-            </a:r>
-            <a:endParaRPr/>
+            <a:r>
+              <a:t>Fecho. A hipotese do slide 6 caiu justamente na metade que dizia que o planejador encontraria planos que o programa nao encontra. O que sobrou, e que os experimentos sustentam, e esta frase: declaratividade mais busca heuristica. Mostre que ela e falseavel nos dois sentidos, como a anterior: tire uma metade e o sistema erra, tire a outra e ele nao termina a tempo. O trunfo do trabalho nao e ter usado Planning, e termos medido COMO ele ajuda, inclusive descobrindo que a resposta nao era a que esperavamos.</a:t>
+            </a:r>
           </a:p>
         </p:txBody>
       </p:sp>
@@ -1728,6 +1718,76 @@
             <a:endParaRPr/>
           </a:p>
         </p:txBody>
+      </p:sp>
+    </p:spTree>
+  </p:cSld>
+  <p:clrMapOvr>
+    <a:masterClrMapping/>
+  </p:clrMapOvr>
+</p:notes>
+</file>
+
+<file path=ppt/notesSlides/notesSlide11.xml><?xml version="1.0" encoding="utf-8"?>
+<p:notes xmlns:a="http://schemas.openxmlformats.org/drawingml/2006/main" xmlns:p="http://schemas.openxmlformats.org/presentationml/2006/main" xmlns:r="http://schemas.openxmlformats.org/officeDocument/2006/relationships">
+  <p:cSld>
+    <p:spTree>
+      <p:nvGrpSpPr>
+        <p:cNvPr id="1" name=""/>
+        <p:cNvGrpSpPr/>
+        <p:nvPr/>
+      </p:nvGrpSpPr>
+      <p:grpSpPr>
+        <a:xfrm>
+          <a:off x="0" y="0"/>
+          <a:ext cx="0" cy="0"/>
+          <a:chOff x="0" y="0"/>
+          <a:chExt cx="0" cy="0"/>
+        </a:xfrm>
+      </p:grpSpPr>
+      <p:sp>
+        <p:nvSpPr>
+          <p:cNvPr id="2" name="Slide Image Placeholder 1"/>
+          <p:cNvSpPr>
+            <a:spLocks noGrp="1"/>
+          </p:cNvSpPr>
+          <p:nvPr>
+            <p:ph type="sldImg" idx="3"/>
+          </p:nvPr>
+        </p:nvSpPr>
+        <p:spPr/>
+      </p:sp>
+      <p:sp>
+        <p:nvSpPr>
+          <p:cNvPr id="3" name="Notes Placeholder 2"/>
+          <p:cNvSpPr>
+            <a:spLocks noGrp="1"/>
+          </p:cNvSpPr>
+          <p:nvPr>
+            <p:ph type="body" idx="1"/>
+          </p:nvPr>
+        </p:nvSpPr>
+        <p:spPr/>
+        <p:txBody>
+          <a:bodyPr/>
+          <a:lstStyle/>
+          <a:p>
+            <a:r>
+              <a:t>Nao leia os seis objetivos um a um: eles cabem em tres verbos. Formalizar e o unico que depende da lei, e e o que trava o resto, porque sem o dominio escrito nao ha o que planejar. Construir e engenharia, e onde esta a maior parte do esforco. Validar e o que separa este trabalho de uma demonstracao. Se perguntarem por que o executor procedural de referencia esta entre os objetivos: porque sem ele a hipotese do slide anterior nao seria testavel.</a:t>
+            </a:r>
+          </a:p>
+        </p:txBody>
+      </p:sp>
+      <p:sp>
+        <p:nvSpPr>
+          <p:cNvPr id="4" name="Slide Number Placeholder 3"/>
+          <p:cNvSpPr>
+            <a:spLocks noGrp="1"/>
+          </p:cNvSpPr>
+          <p:nvPr>
+            <p:ph type="sldNum" idx="12"/>
+          </p:nvPr>
+        </p:nvSpPr>
+        <p:spPr/>
       </p:sp>
     </p:spTree>
   </p:cSld>
@@ -4774,6 +4834,1063 @@
   <p:cSld>
     <p:spTree>
       <p:nvGrpSpPr>
+        <p:cNvPr id="160" name="Shape 160"/>
+        <p:cNvGrpSpPr/>
+        <p:nvPr/>
+      </p:nvGrpSpPr>
+      <p:grpSpPr>
+        <a:xfrm>
+          <a:off x="0" y="0"/>
+          <a:ext cx="0" cy="0"/>
+          <a:chOff x="0" y="0"/>
+          <a:chExt cx="0" cy="0"/>
+        </a:xfrm>
+      </p:grpSpPr>
+      <p:sp>
+        <p:nvSpPr>
+          <p:cNvPr id="161" name="Google Shape;161;p13"/>
+          <p:cNvSpPr/>
+          <p:nvPr/>
+        </p:nvSpPr>
+        <p:spPr>
+          <a:xfrm>
+            <a:off x="411475" y="1380351"/>
+            <a:ext cx="3722400" cy="3900600"/>
+          </a:xfrm>
+          <a:prstGeom prst="roundRect">
+            <a:avLst>
+              <a:gd fmla="val 4000" name="adj"/>
+            </a:avLst>
+          </a:prstGeom>
+          <a:solidFill>
+            <a:srgbClr val="FFFDF8"/>
+          </a:solidFill>
+          <a:ln cap="flat" cmpd="sng" w="9525">
+            <a:solidFill>
+              <a:srgbClr val="E6DCCB"/>
+            </a:solidFill>
+            <a:prstDash val="solid"/>
+            <a:round/>
+            <a:headEnd len="sm" w="sm" type="none"/>
+            <a:tailEnd len="sm" w="sm" type="none"/>
+          </a:ln>
+          <a:effectLst>
+            <a:outerShdw blurRad="127000" rotWithShape="0" algn="bl" dir="5400000" dist="25400">
+              <a:srgbClr val="33291F">
+                <a:alpha val="10196"/>
+              </a:srgbClr>
+            </a:outerShdw>
+          </a:effectLst>
+        </p:spPr>
+        <p:txBody>
+          <a:bodyPr anchorCtr="0" anchor="ctr" bIns="91425" lIns="91425" spcFirstLastPara="1" rIns="91425" wrap="square" tIns="91425">
+            <a:noAutofit/>
+          </a:bodyPr>
+          <a:lstStyle/>
+          <a:p>
+            <a:pPr indent="0" lvl="0" marL="0" rtl="0" algn="just">
+              <a:spcBef>
+                <a:spcPts val="0"/>
+              </a:spcBef>
+              <a:spcAft>
+                <a:spcPts val="0"/>
+              </a:spcAft>
+              <a:buNone/>
+            </a:pPr>
+            <a:r>
+              <a:t/>
+            </a:r>
+            <a:endParaRPr/>
+          </a:p>
+        </p:txBody>
+      </p:sp>
+      <p:sp>
+        <p:nvSpPr>
+          <p:cNvPr id="162" name="Google Shape;162;p13"/>
+          <p:cNvSpPr txBox="1"/>
+          <p:nvPr/>
+        </p:nvSpPr>
+        <p:spPr>
+          <a:xfrm>
+            <a:off x="576319" y="1534230"/>
+            <a:ext cx="2972700" cy="274200"/>
+          </a:xfrm>
+          <a:prstGeom prst="rect">
+            <a:avLst/>
+          </a:prstGeom>
+          <a:noFill/>
+          <a:ln>
+            <a:noFill/>
+          </a:ln>
+        </p:spPr>
+        <p:txBody>
+          <a:bodyPr anchorCtr="0" anchor="ctr" bIns="0" lIns="0" spcFirstLastPara="1" rIns="0" wrap="square" tIns="0">
+            <a:noAutofit/>
+          </a:bodyPr>
+          <a:lstStyle/>
+          <a:p>
+            <a:pPr indent="0" lvl="0" marL="0" marR="0" rtl="0" algn="just">
+              <a:spcBef>
+                <a:spcPts val="0"/>
+              </a:spcBef>
+              <a:spcAft>
+                <a:spcPts val="0"/>
+              </a:spcAft>
+              <a:buClr>
+                <a:srgbClr val="4A6B5B"/>
+              </a:buClr>
+              <a:buSzPts val="1250"/>
+              <a:buFont typeface="Calibri"/>
+              <a:buNone/>
+            </a:pPr>
+            <a:r>
+              <a:rPr b="1" i="0" lang="en-US" sz="2050" u="none" cap="none" strike="noStrike">
+                <a:solidFill>
+                  <a:srgbClr val="4A6B5B"/>
+                </a:solidFill>
+                <a:latin typeface="Calibri"/>
+                <a:ea typeface="Calibri"/>
+                <a:cs typeface="Calibri"/>
+                <a:sym typeface="Calibri"/>
+              </a:rPr>
+              <a:t>A FAVOR</a:t>
+            </a:r>
+            <a:endParaRPr b="0" i="0" sz="2050" u="none" cap="none" strike="noStrike">
+              <a:solidFill>
+                <a:schemeClr val="dk1"/>
+              </a:solidFill>
+              <a:latin typeface="Calibri"/>
+              <a:ea typeface="Calibri"/>
+              <a:cs typeface="Calibri"/>
+              <a:sym typeface="Calibri"/>
+            </a:endParaRPr>
+          </a:p>
+        </p:txBody>
+      </p:sp>
+      <p:sp>
+        <p:nvSpPr>
+          <p:cNvPr id="163" name="Google Shape;163;p13"/>
+          <p:cNvSpPr txBox="1"/>
+          <p:nvPr/>
+        </p:nvSpPr>
+        <p:spPr>
+          <a:xfrm>
+            <a:off x="558176" y="2088313"/>
+            <a:ext cx="3319800" cy="603600"/>
+          </a:xfrm>
+          <a:prstGeom prst="rect">
+            <a:avLst/>
+          </a:prstGeom>
+          <a:noFill/>
+          <a:ln>
+            <a:noFill/>
+          </a:ln>
+        </p:spPr>
+        <p:txBody>
+          <a:bodyPr anchorCtr="0" anchor="ctr" bIns="0" lIns="0" spcFirstLastPara="1" rIns="0" wrap="square" tIns="0">
+            <a:noAutofit/>
+          </a:bodyPr>
+          <a:lstStyle/>
+          <a:p>
+            <a:pPr indent="0" lvl="0" marL="0" marR="0" rtl="0" algn="just">
+              <a:lnSpc>
+                <a:spcPct val="131250"/>
+              </a:lnSpc>
+              <a:spcBef>
+                <a:spcPts val="0"/>
+              </a:spcBef>
+              <a:spcAft>
+                <a:spcPts val="0"/>
+              </a:spcAft>
+              <a:buClr>
+                <a:srgbClr val="33291F"/>
+              </a:buClr>
+              <a:buSzPts val="1600"/>
+              <a:buFont typeface="Cambria"/>
+              <a:buNone/>
+            </a:pPr>
+            <a:r>
+              <a:rPr b="1" i="0" lang="en-US" sz="3000" u="none" cap="none" strike="noStrike">
+                <a:solidFill>
+                  <a:srgbClr val="33291F"/>
+                </a:solidFill>
+                <a:latin typeface="Cambria"/>
+                <a:ea typeface="Cambria"/>
+                <a:cs typeface="Cambria"/>
+                <a:sym typeface="Cambria"/>
+              </a:rPr>
+              <a:t>A busca trivial não escala</a:t>
+            </a:r>
+            <a:endParaRPr b="0" i="0" sz="3000" u="none" cap="none" strike="noStrike">
+              <a:solidFill>
+                <a:schemeClr val="dk1"/>
+              </a:solidFill>
+              <a:latin typeface="Calibri"/>
+              <a:ea typeface="Calibri"/>
+              <a:cs typeface="Calibri"/>
+              <a:sym typeface="Calibri"/>
+            </a:endParaRPr>
+          </a:p>
+        </p:txBody>
+      </p:sp>
+      <p:sp>
+        <p:nvSpPr>
+          <p:cNvPr id="164" name="Google Shape;164;p13"/>
+          <p:cNvSpPr txBox="1"/>
+          <p:nvPr/>
+        </p:nvSpPr>
+        <p:spPr>
+          <a:xfrm>
+            <a:off x="563726" y="2984971"/>
+            <a:ext cx="3417900" cy="914400"/>
+          </a:xfrm>
+          <a:prstGeom prst="rect">
+            <a:avLst/>
+          </a:prstGeom>
+          <a:noFill/>
+          <a:ln>
+            <a:noFill/>
+          </a:ln>
+        </p:spPr>
+        <p:txBody>
+          <a:bodyPr anchorCtr="0" anchor="t" bIns="0" lIns="0" spcFirstLastPara="1" rIns="0" wrap="square" tIns="0">
+            <a:noAutofit/>
+          </a:bodyPr>
+          <a:lstStyle/>
+          <a:p>
+            <a:pPr indent="0" lvl="0" marL="0" marR="0" rtl="0" algn="just">
+              <a:lnSpc>
+                <a:spcPct val="126923"/>
+              </a:lnSpc>
+              <a:spcBef>
+                <a:spcPts val="0"/>
+              </a:spcBef>
+              <a:spcAft>
+                <a:spcPts val="0"/>
+              </a:spcAft>
+              <a:buClr>
+                <a:srgbClr val="5C4F41"/>
+              </a:buClr>
+              <a:buSzPts val="1300"/>
+              <a:buFont typeface="Calibri"/>
+              <a:buNone/>
+            </a:pPr>
+            <a:r>
+              <a:rPr b="0" i="0" lang="en-US" sz="2400" u="none" cap="none" strike="noStrike">
+                <a:solidFill>
+                  <a:srgbClr val="5C4F41"/>
+                </a:solidFill>
+                <a:latin typeface="Calibri"/>
+                <a:ea typeface="Calibri"/>
+                <a:cs typeface="Calibri"/>
+                <a:sym typeface="Calibri"/>
+              </a:rPr>
+              <a:t>Varrer o mesmo modelo declarativo sem heurística resolve até 5 ou 6 pacientes. Um turno real tem de 10 a 15.</a:t>
+            </a:r>
+            <a:endParaRPr b="0" i="0" sz="2400" u="none" cap="none" strike="noStrike">
+              <a:solidFill>
+                <a:schemeClr val="dk1"/>
+              </a:solidFill>
+              <a:latin typeface="Calibri"/>
+              <a:ea typeface="Calibri"/>
+              <a:cs typeface="Calibri"/>
+              <a:sym typeface="Calibri"/>
+            </a:endParaRPr>
+          </a:p>
+        </p:txBody>
+      </p:sp>
+      <p:sp>
+        <p:nvSpPr>
+          <p:cNvPr id="165" name="Google Shape;165;p13"/>
+          <p:cNvSpPr/>
+          <p:nvPr/>
+        </p:nvSpPr>
+        <p:spPr>
+          <a:xfrm>
+            <a:off x="4329450" y="1380400"/>
+            <a:ext cx="3514500" cy="3900600"/>
+          </a:xfrm>
+          <a:prstGeom prst="roundRect">
+            <a:avLst>
+              <a:gd fmla="val 4000" name="adj"/>
+            </a:avLst>
+          </a:prstGeom>
+          <a:solidFill>
+            <a:srgbClr val="FFFDF8"/>
+          </a:solidFill>
+          <a:ln cap="flat" cmpd="sng" w="9525">
+            <a:solidFill>
+              <a:srgbClr val="E6DCCB"/>
+            </a:solidFill>
+            <a:prstDash val="solid"/>
+            <a:round/>
+            <a:headEnd len="sm" w="sm" type="none"/>
+            <a:tailEnd len="sm" w="sm" type="none"/>
+          </a:ln>
+          <a:effectLst>
+            <a:outerShdw blurRad="127000" rotWithShape="0" algn="bl" dir="5400000" dist="25400">
+              <a:srgbClr val="33291F">
+                <a:alpha val="10196"/>
+              </a:srgbClr>
+            </a:outerShdw>
+          </a:effectLst>
+        </p:spPr>
+        <p:txBody>
+          <a:bodyPr anchorCtr="0" anchor="ctr" bIns="91425" lIns="91425" spcFirstLastPara="1" rIns="91425" wrap="square" tIns="91425">
+            <a:noAutofit/>
+          </a:bodyPr>
+          <a:lstStyle/>
+          <a:p>
+            <a:pPr indent="0" lvl="0" marL="0" rtl="0" algn="just">
+              <a:spcBef>
+                <a:spcPts val="0"/>
+              </a:spcBef>
+              <a:spcAft>
+                <a:spcPts val="0"/>
+              </a:spcAft>
+              <a:buNone/>
+            </a:pPr>
+            <a:r>
+              <a:t/>
+            </a:r>
+            <a:endParaRPr/>
+          </a:p>
+        </p:txBody>
+      </p:sp>
+      <p:sp>
+        <p:nvSpPr>
+          <p:cNvPr id="166" name="Google Shape;166;p13"/>
+          <p:cNvSpPr txBox="1"/>
+          <p:nvPr/>
+        </p:nvSpPr>
+        <p:spPr>
+          <a:xfrm>
+            <a:off x="4457565" y="1534168"/>
+            <a:ext cx="2972700" cy="274200"/>
+          </a:xfrm>
+          <a:prstGeom prst="rect">
+            <a:avLst/>
+          </a:prstGeom>
+          <a:noFill/>
+          <a:ln>
+            <a:noFill/>
+          </a:ln>
+        </p:spPr>
+        <p:txBody>
+          <a:bodyPr anchorCtr="0" anchor="ctr" bIns="0" lIns="0" spcFirstLastPara="1" rIns="0" wrap="square" tIns="0">
+            <a:noAutofit/>
+          </a:bodyPr>
+          <a:lstStyle/>
+          <a:p>
+            <a:pPr indent="0" lvl="0" marL="0" marR="0" rtl="0" algn="just">
+              <a:spcBef>
+                <a:spcPts val="0"/>
+              </a:spcBef>
+              <a:spcAft>
+                <a:spcPts val="0"/>
+              </a:spcAft>
+              <a:buClr>
+                <a:srgbClr val="4A6B5B"/>
+              </a:buClr>
+              <a:buSzPts val="1250"/>
+              <a:buFont typeface="Calibri"/>
+              <a:buNone/>
+            </a:pPr>
+            <a:r>
+              <a:rPr b="1" i="0" lang="en-US" sz="2050" u="none" cap="none" strike="noStrike">
+                <a:solidFill>
+                  <a:srgbClr val="4A6B5B"/>
+                </a:solidFill>
+                <a:latin typeface="Calibri"/>
+                <a:ea typeface="Calibri"/>
+                <a:cs typeface="Calibri"/>
+                <a:sym typeface="Calibri"/>
+              </a:rPr>
+              <a:t>A FAVOR</a:t>
+            </a:r>
+            <a:endParaRPr b="0" i="0" sz="2050" u="none" cap="none" strike="noStrike">
+              <a:solidFill>
+                <a:schemeClr val="dk1"/>
+              </a:solidFill>
+              <a:latin typeface="Calibri"/>
+              <a:ea typeface="Calibri"/>
+              <a:cs typeface="Calibri"/>
+              <a:sym typeface="Calibri"/>
+            </a:endParaRPr>
+          </a:p>
+        </p:txBody>
+      </p:sp>
+      <p:sp>
+        <p:nvSpPr>
+          <p:cNvPr id="167" name="Google Shape;167;p13"/>
+          <p:cNvSpPr txBox="1"/>
+          <p:nvPr/>
+        </p:nvSpPr>
+        <p:spPr>
+          <a:xfrm>
+            <a:off x="4460351" y="2011675"/>
+            <a:ext cx="3235500" cy="603600"/>
+          </a:xfrm>
+          <a:prstGeom prst="rect">
+            <a:avLst/>
+          </a:prstGeom>
+          <a:noFill/>
+          <a:ln>
+            <a:noFill/>
+          </a:ln>
+        </p:spPr>
+        <p:txBody>
+          <a:bodyPr anchorCtr="0" anchor="ctr" bIns="0" lIns="0" spcFirstLastPara="1" rIns="0" wrap="square" tIns="0">
+            <a:noAutofit/>
+          </a:bodyPr>
+          <a:lstStyle/>
+          <a:p>
+            <a:pPr indent="0" lvl="0" marL="0" marR="0" rtl="0" algn="just">
+              <a:lnSpc>
+                <a:spcPct val="131250"/>
+              </a:lnSpc>
+              <a:spcBef>
+                <a:spcPts val="0"/>
+              </a:spcBef>
+              <a:spcAft>
+                <a:spcPts val="0"/>
+              </a:spcAft>
+              <a:buClr>
+                <a:srgbClr val="33291F"/>
+              </a:buClr>
+              <a:buSzPts val="1600"/>
+              <a:buFont typeface="Cambria"/>
+              <a:buNone/>
+            </a:pPr>
+            <a:r>
+              <a:rPr b="1" i="0" lang="en-US" sz="3000" u="none" cap="none" strike="noStrike">
+                <a:solidFill>
+                  <a:srgbClr val="33291F"/>
+                </a:solidFill>
+                <a:latin typeface="Cambria"/>
+                <a:ea typeface="Cambria"/>
+                <a:cs typeface="Cambria"/>
+                <a:sym typeface="Cambria"/>
+              </a:rPr>
+              <a:t>O planejador está correto</a:t>
+            </a:r>
+            <a:endParaRPr b="0" i="0" sz="3000" u="none" cap="none" strike="noStrike">
+              <a:solidFill>
+                <a:schemeClr val="dk1"/>
+              </a:solidFill>
+              <a:latin typeface="Calibri"/>
+              <a:ea typeface="Calibri"/>
+              <a:cs typeface="Calibri"/>
+              <a:sym typeface="Calibri"/>
+            </a:endParaRPr>
+          </a:p>
+        </p:txBody>
+      </p:sp>
+      <p:sp>
+        <p:nvSpPr>
+          <p:cNvPr id="168" name="Google Shape;168;p13"/>
+          <p:cNvSpPr txBox="1"/>
+          <p:nvPr/>
+        </p:nvSpPr>
+        <p:spPr>
+          <a:xfrm>
+            <a:off x="4457575" y="3017525"/>
+            <a:ext cx="3235500" cy="914400"/>
+          </a:xfrm>
+          <a:prstGeom prst="rect">
+            <a:avLst/>
+          </a:prstGeom>
+          <a:noFill/>
+          <a:ln>
+            <a:noFill/>
+          </a:ln>
+        </p:spPr>
+        <p:txBody>
+          <a:bodyPr anchorCtr="0" anchor="t" bIns="0" lIns="0" spcFirstLastPara="1" rIns="0" wrap="square" tIns="0">
+            <a:noAutofit/>
+          </a:bodyPr>
+          <a:lstStyle/>
+          <a:p>
+            <a:pPr indent="0" lvl="0" marL="0" marR="0" rtl="0" algn="just">
+              <a:lnSpc>
+                <a:spcPct val="126923"/>
+              </a:lnSpc>
+              <a:spcBef>
+                <a:spcPts val="0"/>
+              </a:spcBef>
+              <a:spcAft>
+                <a:spcPts val="0"/>
+              </a:spcAft>
+              <a:buClr>
+                <a:srgbClr val="5C4F41"/>
+              </a:buClr>
+              <a:buSzPts val="1300"/>
+              <a:buFont typeface="Calibri"/>
+              <a:buNone/>
+            </a:pPr>
+            <a:r>
+              <a:rPr b="0" i="0" lang="en-US" sz="2200" u="none" cap="none" strike="noStrike">
+                <a:solidFill>
+                  <a:srgbClr val="5C4F41"/>
+                </a:solidFill>
+                <a:latin typeface="Calibri"/>
+                <a:ea typeface="Calibri"/>
+                <a:cs typeface="Calibri"/>
+                <a:sym typeface="Calibri"/>
+              </a:rPr>
+              <a:t>Um planejador de referência independente concordou sobre viabilidade e plano mínimo em todas as instâncias testadas.</a:t>
+            </a:r>
+            <a:endParaRPr b="0" i="0" sz="2200" u="none" cap="none" strike="noStrike">
+              <a:solidFill>
+                <a:schemeClr val="dk1"/>
+              </a:solidFill>
+              <a:latin typeface="Calibri"/>
+              <a:ea typeface="Calibri"/>
+              <a:cs typeface="Calibri"/>
+              <a:sym typeface="Calibri"/>
+            </a:endParaRPr>
+          </a:p>
+        </p:txBody>
+      </p:sp>
+      <p:sp>
+        <p:nvSpPr>
+          <p:cNvPr id="169" name="Google Shape;169;p13"/>
+          <p:cNvSpPr/>
+          <p:nvPr/>
+        </p:nvSpPr>
+        <p:spPr>
+          <a:xfrm>
+            <a:off x="8015400" y="1380301"/>
+            <a:ext cx="3490500" cy="3900600"/>
+          </a:xfrm>
+          <a:prstGeom prst="roundRect">
+            <a:avLst>
+              <a:gd fmla="val 4000" name="adj"/>
+            </a:avLst>
+          </a:prstGeom>
+          <a:solidFill>
+            <a:srgbClr val="F3DFD3"/>
+          </a:solidFill>
+          <a:ln cap="flat" cmpd="sng" w="9525">
+            <a:solidFill>
+              <a:srgbClr val="E6DCCB"/>
+            </a:solidFill>
+            <a:prstDash val="solid"/>
+            <a:round/>
+            <a:headEnd len="sm" w="sm" type="none"/>
+            <a:tailEnd len="sm" w="sm" type="none"/>
+          </a:ln>
+          <a:effectLst>
+            <a:outerShdw blurRad="127000" rotWithShape="0" algn="bl" dir="5400000" dist="25400">
+              <a:srgbClr val="33291F">
+                <a:alpha val="10196"/>
+              </a:srgbClr>
+            </a:outerShdw>
+          </a:effectLst>
+        </p:spPr>
+        <p:txBody>
+          <a:bodyPr anchorCtr="0" anchor="ctr" bIns="91425" lIns="91425" spcFirstLastPara="1" rIns="91425" wrap="square" tIns="91425">
+            <a:noAutofit/>
+          </a:bodyPr>
+          <a:lstStyle/>
+          <a:p>
+            <a:pPr indent="0" lvl="0" marL="0" rtl="0" algn="just">
+              <a:spcBef>
+                <a:spcPts val="0"/>
+              </a:spcBef>
+              <a:spcAft>
+                <a:spcPts val="0"/>
+              </a:spcAft>
+              <a:buNone/>
+            </a:pPr>
+            <a:r>
+              <a:t/>
+            </a:r>
+            <a:endParaRPr/>
+          </a:p>
+        </p:txBody>
+      </p:sp>
+      <p:sp>
+        <p:nvSpPr>
+          <p:cNvPr id="170" name="Google Shape;170;p13"/>
+          <p:cNvSpPr txBox="1"/>
+          <p:nvPr/>
+        </p:nvSpPr>
+        <p:spPr>
+          <a:xfrm>
+            <a:off x="8089262" y="1523316"/>
+            <a:ext cx="2972700" cy="274200"/>
+          </a:xfrm>
+          <a:prstGeom prst="rect">
+            <a:avLst/>
+          </a:prstGeom>
+          <a:noFill/>
+          <a:ln>
+            <a:noFill/>
+          </a:ln>
+        </p:spPr>
+        <p:txBody>
+          <a:bodyPr anchorCtr="0" anchor="ctr" bIns="0" lIns="0" spcFirstLastPara="1" rIns="0" wrap="square" tIns="0">
+            <a:noAutofit/>
+          </a:bodyPr>
+          <a:lstStyle/>
+          <a:p>
+            <a:pPr indent="0" lvl="0" marL="0" marR="0" rtl="0" algn="just">
+              <a:spcBef>
+                <a:spcPts val="0"/>
+              </a:spcBef>
+              <a:spcAft>
+                <a:spcPts val="0"/>
+              </a:spcAft>
+              <a:buClr>
+                <a:srgbClr val="B35C38"/>
+              </a:buClr>
+              <a:buSzPts val="1250"/>
+              <a:buFont typeface="Calibri"/>
+              <a:buNone/>
+            </a:pPr>
+            <a:r>
+              <a:rPr b="1" i="0" lang="en-US" sz="2050" u="none" cap="none" strike="noStrike">
+                <a:solidFill>
+                  <a:srgbClr val="B35C38"/>
+                </a:solidFill>
+                <a:latin typeface="Calibri"/>
+                <a:ea typeface="Calibri"/>
+                <a:cs typeface="Calibri"/>
+                <a:sym typeface="Calibri"/>
+              </a:rPr>
+              <a:t>CONTRA A HIPÓTESE</a:t>
+            </a:r>
+            <a:endParaRPr b="0" i="0" sz="2050" u="none" cap="none" strike="noStrike">
+              <a:solidFill>
+                <a:schemeClr val="dk1"/>
+              </a:solidFill>
+              <a:latin typeface="Calibri"/>
+              <a:ea typeface="Calibri"/>
+              <a:cs typeface="Calibri"/>
+              <a:sym typeface="Calibri"/>
+            </a:endParaRPr>
+          </a:p>
+        </p:txBody>
+      </p:sp>
+      <p:sp>
+        <p:nvSpPr>
+          <p:cNvPr id="171" name="Google Shape;171;p13"/>
+          <p:cNvSpPr txBox="1"/>
+          <p:nvPr/>
+        </p:nvSpPr>
+        <p:spPr>
+          <a:xfrm>
+            <a:off x="8089250" y="2011725"/>
+            <a:ext cx="3235500" cy="603600"/>
+          </a:xfrm>
+          <a:prstGeom prst="rect">
+            <a:avLst/>
+          </a:prstGeom>
+          <a:noFill/>
+          <a:ln>
+            <a:noFill/>
+          </a:ln>
+        </p:spPr>
+        <p:txBody>
+          <a:bodyPr anchorCtr="0" anchor="ctr" bIns="0" lIns="0" spcFirstLastPara="1" rIns="0" wrap="square" tIns="0">
+            <a:noAutofit/>
+          </a:bodyPr>
+          <a:lstStyle/>
+          <a:p>
+            <a:pPr indent="0" lvl="0" marL="0" marR="0" rtl="0" algn="just">
+              <a:lnSpc>
+                <a:spcPct val="131250"/>
+              </a:lnSpc>
+              <a:spcBef>
+                <a:spcPts val="0"/>
+              </a:spcBef>
+              <a:spcAft>
+                <a:spcPts val="0"/>
+              </a:spcAft>
+              <a:buClr>
+                <a:srgbClr val="33291F"/>
+              </a:buClr>
+              <a:buSzPts val="1600"/>
+              <a:buFont typeface="Cambria"/>
+              <a:buNone/>
+            </a:pPr>
+            <a:r>
+              <a:rPr b="1" i="0" lang="en-US" sz="3000" u="none" cap="none" strike="noStrike">
+                <a:solidFill>
+                  <a:srgbClr val="33291F"/>
+                </a:solidFill>
+                <a:latin typeface="Cambria"/>
+                <a:ea typeface="Cambria"/>
+                <a:cs typeface="Cambria"/>
+                <a:sym typeface="Cambria"/>
+              </a:rPr>
+              <a:t>A hipótese foi </a:t>
+            </a:r>
+            <a:r>
+              <a:rPr b="1" lang="en-US" sz="3000">
+                <a:solidFill>
+                  <a:srgbClr val="33291F"/>
+                </a:solidFill>
+                <a:latin typeface="Cambria"/>
+                <a:ea typeface="Cambria"/>
+                <a:cs typeface="Cambria"/>
+                <a:sym typeface="Cambria"/>
+              </a:rPr>
+              <a:t>“</a:t>
+            </a:r>
+            <a:r>
+              <a:rPr b="1" i="0" lang="en-US" sz="3000" u="none" cap="none" strike="noStrike">
+                <a:solidFill>
+                  <a:srgbClr val="33291F"/>
+                </a:solidFill>
+                <a:latin typeface="Cambria"/>
+                <a:ea typeface="Cambria"/>
+                <a:cs typeface="Cambria"/>
+                <a:sym typeface="Cambria"/>
+              </a:rPr>
+              <a:t>refutada</a:t>
+            </a:r>
+            <a:r>
+              <a:rPr b="1" lang="en-US" sz="3000">
+                <a:solidFill>
+                  <a:srgbClr val="33291F"/>
+                </a:solidFill>
+                <a:latin typeface="Cambria"/>
+                <a:ea typeface="Cambria"/>
+                <a:cs typeface="Cambria"/>
+                <a:sym typeface="Cambria"/>
+              </a:rPr>
+              <a:t>”</a:t>
+            </a:r>
+            <a:endParaRPr b="0" i="0" sz="3000" u="none" cap="none" strike="noStrike">
+              <a:solidFill>
+                <a:schemeClr val="dk1"/>
+              </a:solidFill>
+              <a:latin typeface="Calibri"/>
+              <a:ea typeface="Calibri"/>
+              <a:cs typeface="Calibri"/>
+              <a:sym typeface="Calibri"/>
+            </a:endParaRPr>
+          </a:p>
+        </p:txBody>
+      </p:sp>
+      <p:sp>
+        <p:nvSpPr>
+          <p:cNvPr id="172" name="Google Shape;172;p13"/>
+          <p:cNvSpPr txBox="1"/>
+          <p:nvPr/>
+        </p:nvSpPr>
+        <p:spPr>
+          <a:xfrm>
+            <a:off x="8089250" y="2984971"/>
+            <a:ext cx="3235500" cy="914400"/>
+          </a:xfrm>
+          <a:prstGeom prst="rect">
+            <a:avLst/>
+          </a:prstGeom>
+          <a:noFill/>
+          <a:ln>
+            <a:noFill/>
+          </a:ln>
+        </p:spPr>
+        <p:txBody>
+          <a:bodyPr anchorCtr="0" anchor="t" bIns="0" lIns="0" spcFirstLastPara="1" rIns="0" wrap="square" tIns="0">
+            <a:noAutofit/>
+          </a:bodyPr>
+          <a:lstStyle/>
+          <a:p>
+            <a:pPr indent="0" lvl="0" marL="0" marR="0" rtl="0" algn="just">
+              <a:lnSpc>
+                <a:spcPct val="126923"/>
+              </a:lnSpc>
+              <a:spcBef>
+                <a:spcPts val="0"/>
+              </a:spcBef>
+              <a:spcAft>
+                <a:spcPts val="0"/>
+              </a:spcAft>
+              <a:buClr>
+                <a:srgbClr val="5C4F41"/>
+              </a:buClr>
+              <a:buSzPts val="1300"/>
+              <a:buFont typeface="Calibri"/>
+              <a:buNone/>
+            </a:pPr>
+            <a:r>
+              <a:rPr b="0" i="0" lang="en-US" sz="2400" u="none" cap="none" strike="noStrike">
+                <a:solidFill>
+                  <a:srgbClr val="5C4F41"/>
+                </a:solidFill>
+                <a:latin typeface="Calibri"/>
+                <a:ea typeface="Calibri"/>
+                <a:cs typeface="Calibri"/>
+                <a:sym typeface="Calibri"/>
+              </a:rPr>
+              <a:t>Uma correção manual no executor procedural zera os falsos negativos. Ele não era incapaz: faltava-lhe a regra.</a:t>
+            </a:r>
+            <a:endParaRPr b="0" i="0" sz="2400" u="none" cap="none" strike="noStrike">
+              <a:solidFill>
+                <a:schemeClr val="dk1"/>
+              </a:solidFill>
+              <a:latin typeface="Calibri"/>
+              <a:ea typeface="Calibri"/>
+              <a:cs typeface="Calibri"/>
+              <a:sym typeface="Calibri"/>
+            </a:endParaRPr>
+          </a:p>
+        </p:txBody>
+      </p:sp>
+      <p:sp>
+        <p:nvSpPr>
+          <p:cNvPr id="173" name="Google Shape;173;p13"/>
+          <p:cNvSpPr/>
+          <p:nvPr/>
+        </p:nvSpPr>
+        <p:spPr>
+          <a:xfrm>
+            <a:off x="685950" y="5503383"/>
+            <a:ext cx="10820100" cy="713100"/>
+          </a:xfrm>
+          <a:prstGeom prst="roundRect">
+            <a:avLst>
+              <a:gd fmla="val 11538" name="adj"/>
+            </a:avLst>
+          </a:prstGeom>
+          <a:solidFill>
+            <a:srgbClr val="F3DFD3"/>
+          </a:solidFill>
+          <a:ln>
+            <a:noFill/>
+          </a:ln>
+        </p:spPr>
+        <p:txBody>
+          <a:bodyPr anchorCtr="0" anchor="ctr" bIns="91425" lIns="91425" spcFirstLastPara="1" rIns="91425" wrap="square" tIns="91425">
+            <a:noAutofit/>
+          </a:bodyPr>
+          <a:lstStyle/>
+          <a:p>
+            <a:pPr indent="0" lvl="0" marL="0" rtl="0" algn="just">
+              <a:spcBef>
+                <a:spcPts val="0"/>
+              </a:spcBef>
+              <a:spcAft>
+                <a:spcPts val="0"/>
+              </a:spcAft>
+              <a:buNone/>
+            </a:pPr>
+            <a:r>
+              <a:t/>
+            </a:r>
+            <a:endParaRPr/>
+          </a:p>
+        </p:txBody>
+      </p:sp>
+      <p:sp>
+        <p:nvSpPr>
+          <p:cNvPr id="174" name="Google Shape;174;p13"/>
+          <p:cNvSpPr txBox="1"/>
+          <p:nvPr/>
+        </p:nvSpPr>
+        <p:spPr>
+          <a:xfrm>
+            <a:off x="960270" y="5576535"/>
+            <a:ext cx="10271400" cy="567000"/>
+          </a:xfrm>
+          <a:prstGeom prst="rect">
+            <a:avLst/>
+          </a:prstGeom>
+          <a:noFill/>
+          <a:ln>
+            <a:noFill/>
+          </a:ln>
+        </p:spPr>
+        <p:txBody>
+          <a:bodyPr anchorCtr="0" anchor="ctr" bIns="0" lIns="0" spcFirstLastPara="1" rIns="0" wrap="square" tIns="0">
+            <a:noAutofit/>
+          </a:bodyPr>
+          <a:lstStyle/>
+          <a:p>
+            <a:pPr indent="0" lvl="0" marL="0" marR="0" rtl="0" algn="ctr">
+              <a:lnSpc>
+                <a:spcPct val="122580"/>
+              </a:lnSpc>
+              <a:spcBef>
+                <a:spcPts val="0"/>
+              </a:spcBef>
+              <a:spcAft>
+                <a:spcPts val="0"/>
+              </a:spcAft>
+              <a:buClr>
+                <a:srgbClr val="33291F"/>
+              </a:buClr>
+              <a:buSzPts val="1550"/>
+              <a:buFont typeface="Cambria"/>
+              <a:buNone/>
+            </a:pPr>
+            <a:r>
+              <a:rPr b="0" i="1" lang="en-US" sz="2400" u="none" cap="none" strike="noStrike">
+                <a:solidFill>
+                  <a:srgbClr val="33291F"/>
+                </a:solidFill>
+                <a:latin typeface="Cambria"/>
+                <a:ea typeface="Cambria"/>
+                <a:cs typeface="Cambria"/>
+                <a:sym typeface="Cambria"/>
+              </a:rPr>
+              <a:t>O caminho 1 de erro, previsto no slide da hipótese, foi o que se materializou.</a:t>
+            </a:r>
+            <a:endParaRPr b="0" i="0" sz="2400" u="none" cap="none" strike="noStrike">
+              <a:solidFill>
+                <a:schemeClr val="dk1"/>
+              </a:solidFill>
+              <a:latin typeface="Calibri"/>
+              <a:ea typeface="Calibri"/>
+              <a:cs typeface="Calibri"/>
+              <a:sym typeface="Calibri"/>
+            </a:endParaRPr>
+          </a:p>
+        </p:txBody>
+      </p:sp>
+      <p:sp>
+        <p:nvSpPr>
+          <p:cNvPr id="175" name="Google Shape;175;p13"/>
+          <p:cNvSpPr txBox="1"/>
+          <p:nvPr>
+            <p:ph idx="4294967295" type="sldNum"/>
+          </p:nvPr>
+        </p:nvSpPr>
+        <p:spPr>
+          <a:xfrm>
+            <a:off x="11384280" y="6327648"/>
+            <a:ext cx="365760" cy="274320"/>
+          </a:xfrm>
+          <a:prstGeom prst="rect">
+            <a:avLst/>
+          </a:prstGeom>
+          <a:noFill/>
+          <a:ln>
+            <a:noFill/>
+          </a:ln>
+        </p:spPr>
+        <p:txBody>
+          <a:bodyPr anchorCtr="0" anchor="t" bIns="45700" lIns="91425" spcFirstLastPara="1" rIns="91425" wrap="square" tIns="45700">
+            <a:noAutofit/>
+          </a:bodyPr>
+          <a:lstStyle/>
+          <a:p>
+            <a:pPr indent="0" lvl="0" marL="0" marR="0" rtl="0" algn="r">
+              <a:spcBef>
+                <a:spcPts val="0"/>
+              </a:spcBef>
+              <a:spcAft>
+                <a:spcPts val="0"/>
+              </a:spcAft>
+              <a:buNone/>
+            </a:pPr>
+            <a:fld id="{00000000-1234-1234-1234-123412341234}" type="slidenum">
+              <a:rPr b="0" i="0" lang="en-US" sz="1000" u="none" cap="none" strike="noStrike">
+                <a:solidFill>
+                  <a:srgbClr val="8A7A67"/>
+                </a:solidFill>
+                <a:latin typeface="Calibri"/>
+                <a:ea typeface="Calibri"/>
+                <a:cs typeface="Calibri"/>
+                <a:sym typeface="Calibri"/>
+              </a:rPr>
+              <a:t>‹#›</a:t>
+            </a:fld>
+            <a:endParaRPr b="0" i="0" sz="1000" u="none" cap="none" strike="noStrike">
+              <a:solidFill>
+                <a:srgbClr val="8A7A67"/>
+              </a:solidFill>
+              <a:latin typeface="Calibri"/>
+              <a:ea typeface="Calibri"/>
+              <a:cs typeface="Calibri"/>
+              <a:sym typeface="Calibri"/>
+            </a:endParaRPr>
+          </a:p>
+        </p:txBody>
+      </p:sp>
+      <p:sp>
+        <p:nvSpPr>
+          <p:cNvPr id="176" name="Google Shape;176;p13"/>
+          <p:cNvSpPr txBox="1"/>
+          <p:nvPr/>
+        </p:nvSpPr>
+        <p:spPr>
+          <a:xfrm>
+            <a:off x="411475" y="304883"/>
+            <a:ext cx="10820100" cy="868800"/>
+          </a:xfrm>
+          <a:prstGeom prst="rect">
+            <a:avLst/>
+          </a:prstGeom>
+          <a:noFill/>
+          <a:ln>
+            <a:noFill/>
+          </a:ln>
+        </p:spPr>
+        <p:txBody>
+          <a:bodyPr anchorCtr="0" anchor="t" bIns="0" lIns="0" spcFirstLastPara="1" rIns="0" wrap="square" tIns="0">
+            <a:noAutofit/>
+          </a:bodyPr>
+          <a:lstStyle/>
+          <a:p>
+            <a:pPr indent="0" lvl="0" marL="0" marR="0" rtl="0" algn="just">
+              <a:lnSpc>
+                <a:spcPct val="111764"/>
+              </a:lnSpc>
+              <a:spcBef>
+                <a:spcPts val="0"/>
+              </a:spcBef>
+              <a:spcAft>
+                <a:spcPts val="0"/>
+              </a:spcAft>
+              <a:buClr>
+                <a:srgbClr val="33291F"/>
+              </a:buClr>
+              <a:buSzPts val="3400"/>
+              <a:buFont typeface="Cambria"/>
+              <a:buNone/>
+            </a:pPr>
+            <a:r>
+              <a:rPr b="1" lang="en-US" sz="4800">
+                <a:solidFill>
+                  <a:srgbClr val="33291F"/>
+                </a:solidFill>
+                <a:latin typeface="Cambria"/>
+                <a:ea typeface="Cambria"/>
+                <a:cs typeface="Cambria"/>
+                <a:sym typeface="Cambria"/>
+              </a:rPr>
+              <a:t>RESULTADOS JÁ OBTIDOS</a:t>
+            </a:r>
+            <a:endParaRPr b="1" sz="4800">
+              <a:solidFill>
+                <a:srgbClr val="33291F"/>
+              </a:solidFill>
+              <a:latin typeface="Cambria"/>
+              <a:ea typeface="Cambria"/>
+              <a:cs typeface="Cambria"/>
+              <a:sym typeface="Cambria"/>
+            </a:endParaRPr>
+          </a:p>
+        </p:txBody>
+      </p:sp>
+    </p:spTree>
+  </p:cSld>
+  <p:clrMapOvr>
+    <a:masterClrMapping/>
+  </p:clrMapOvr>
+</p:sld>
+</file>
+
+<file path=ppt/slides/slide11.xml><?xml version="1.0" encoding="utf-8"?>
+<p:sld xmlns:a="http://schemas.openxmlformats.org/drawingml/2006/main" xmlns:r="http://schemas.openxmlformats.org/officeDocument/2006/relationships" xmlns:mc="http://schemas.openxmlformats.org/markup-compatibility/2006" xmlns:mv="urn:schemas-microsoft-com:mac:vml" xmlns:p="http://schemas.openxmlformats.org/presentationml/2006/main" xmlns:c="http://schemas.openxmlformats.org/drawingml/2006/chart" xmlns:dgm="http://schemas.openxmlformats.org/drawingml/2006/diagram" xmlns:o="urn:schemas-microsoft-com:office:office" xmlns:v="urn:schemas-microsoft-com:vml" xmlns:pvml="urn:schemas-microsoft-com:office:powerpoint" xmlns:com="http://schemas.openxmlformats.org/drawingml/2006/compatibility" xmlns:p14="http://schemas.microsoft.com/office/powerpoint/2010/main" xmlns:p15="http://schemas.microsoft.com/office/powerpoint/2012/main" xmlns:ahyp="http://schemas.microsoft.com/office/drawing/2018/hyperlinkcolor">
+  <p:cSld>
+    <p:spTree>
+      <p:nvGrpSpPr>
         <p:cNvPr id="181" name="Shape 181"/>
         <p:cNvGrpSpPr/>
         <p:nvPr/>
@@ -4794,8 +5911,8 @@
         </p:nvSpPr>
         <p:spPr>
           <a:xfrm>
-            <a:off x="685800" y="1755648"/>
-            <a:ext cx="10820100" cy="1417200"/>
+            <a:off x="685800" y="1170432"/>
+            <a:ext cx="10817352" cy="1481328"/>
           </a:xfrm>
           <a:prstGeom prst="roundRect">
             <a:avLst>
@@ -4839,8 +5956,8 @@
         </p:nvSpPr>
         <p:spPr>
           <a:xfrm>
-            <a:off x="996696" y="1938528"/>
-            <a:ext cx="10198200" cy="1060800"/>
+            <a:off x="960120" y="1243584"/>
+            <a:ext cx="10268712" cy="1389888"/>
           </a:xfrm>
           <a:prstGeom prst="rect">
             <a:avLst/>
@@ -4874,7 +5991,7 @@
               <a:buNone/>
             </a:pPr>
             <a:r>
-              <a:rPr b="1" i="0" lang="en-US" sz="2000" u="none" cap="none" strike="noStrike">
+              <a:rPr b="1" i="0" lang="en-US" sz="2800" u="none" cap="none" strike="noStrike">
                 <a:solidFill>
                   <a:srgbClr val="33291F"/>
                 </a:solidFill>
@@ -4883,7 +6000,7 @@
                 <a:cs typeface="Cambria"/>
                 <a:sym typeface="Cambria"/>
               </a:rPr>
-              <a:t>O executor procedural depende de alguém descobrir cada interação entre regras antes de respeitá-la. O planejamento, não.</a:t>
+              <a:t>“Manter a norma como especificação declarativa preserva a corretude do sistema diante de regras novas, a um custo de busca que ainda cabe num turno real.”</a:t>
             </a:r>
             <a:endParaRPr b="0" i="0" sz="2000" u="none" cap="none" strike="noStrike">
               <a:solidFill>
@@ -4905,8 +6022,8 @@
         </p:nvSpPr>
         <p:spPr>
           <a:xfrm>
-            <a:off x="685800" y="3419856"/>
-            <a:ext cx="5047500" cy="1700700"/>
+            <a:off x="685800" y="2788920"/>
+            <a:ext cx="5047488" cy="2423160"/>
           </a:xfrm>
           <a:prstGeom prst="roundRect">
             <a:avLst>
@@ -4963,8 +6080,8 @@
         </p:nvSpPr>
         <p:spPr>
           <a:xfrm>
-            <a:off x="923544" y="3621024"/>
-            <a:ext cx="4572000" cy="274200"/>
+            <a:off x="923544" y="2944368"/>
+            <a:ext cx="4572000" cy="402336"/>
           </a:xfrm>
           <a:prstGeom prst="rect">
             <a:avLst/>
@@ -4995,16 +6112,16 @@
               <a:buNone/>
             </a:pPr>
             <a:r>
-              <a:rPr b="1" i="0" lang="en-US" sz="1250" u="none" cap="none" strike="noStrike">
-                <a:solidFill>
-                  <a:srgbClr val="4A6B5B"/>
+              <a:rPr b="1" i="0" lang="en-US" sz="2000" u="none" cap="none" strike="noStrike">
+                <a:solidFill>
+                  <a:srgbClr val="B35C38"/>
                 </a:solidFill>
                 <a:latin typeface="Calibri"/>
                 <a:ea typeface="Calibri"/>
                 <a:cs typeface="Calibri"/>
                 <a:sym typeface="Calibri"/>
               </a:rPr>
-              <a:t>O QUE SUSTENTAMOS</a:t>
+              <a:t>TIRE A CAMADA DECLARATIVA</a:t>
             </a:r>
             <a:endParaRPr b="0" i="0" sz="1250" u="none" cap="none" strike="noStrike">
               <a:solidFill>
@@ -5026,8 +6143,8 @@
         </p:nvSpPr>
         <p:spPr>
           <a:xfrm>
-            <a:off x="923544" y="3950208"/>
-            <a:ext cx="4572000" cy="384000"/>
+            <a:off x="923544" y="3401568"/>
+            <a:ext cx="4700016" cy="557784"/>
           </a:xfrm>
           <a:prstGeom prst="rect">
             <a:avLst/>
@@ -5061,7 +6178,7 @@
               <a:buNone/>
             </a:pPr>
             <a:r>
-              <a:rPr b="1" i="0" lang="en-US" sz="1700" u="none" cap="none" strike="noStrike">
+              <a:rPr b="1" i="0" lang="en-US" sz="3000" u="none" cap="none" strike="noStrike">
                 <a:solidFill>
                   <a:srgbClr val="33291F"/>
                 </a:solidFill>
@@ -5070,7 +6187,7 @@
                 <a:cs typeface="Cambria"/>
                 <a:sym typeface="Cambria"/>
               </a:rPr>
-              <a:t>Declaratividade e prova</a:t>
+              <a:t>A corretude se perde</a:t>
             </a:r>
             <a:endParaRPr b="0" i="0" sz="1700" u="none" cap="none" strike="noStrike">
               <a:solidFill>
@@ -5092,8 +6209,8 @@
         </p:nvSpPr>
         <p:spPr>
           <a:xfrm>
-            <a:off x="923544" y="4407408"/>
-            <a:ext cx="4572000" cy="548700"/>
+            <a:off x="923544" y="4023360"/>
+            <a:ext cx="4700016" cy="1143000"/>
           </a:xfrm>
           <a:prstGeom prst="rect">
             <a:avLst/>
@@ -5127,7 +6244,7 @@
               <a:buNone/>
             </a:pPr>
             <a:r>
-              <a:rPr b="0" i="0" lang="en-US" sz="1350" u="none" cap="none" strike="noStrike">
+              <a:rPr b="0" i="0" lang="en-US" sz="2200" u="none" cap="none" strike="noStrike">
                 <a:solidFill>
                   <a:srgbClr val="5C4F41"/>
                 </a:solidFill>
@@ -5136,7 +6253,7 @@
                 <a:cs typeface="Calibri"/>
                 <a:sym typeface="Calibri"/>
               </a:rPr>
-              <a:t>Regra nova é absorvida sem tocar no código de busca, e a inviabilidade é demonstrada, não apenas constatada.</a:t>
+              <a:t>O programa procedural volta a falhar assim que entra uma regra que ninguém previu ao escrevê-lo.</a:t>
             </a:r>
             <a:endParaRPr b="0" i="0" sz="1350" u="none" cap="none" strike="noStrike">
               <a:solidFill>
@@ -5158,8 +6275,8 @@
         </p:nvSpPr>
         <p:spPr>
           <a:xfrm>
-            <a:off x="5971032" y="3419856"/>
-            <a:ext cx="5047500" cy="1700700"/>
+            <a:off x="5971032" y="2788920"/>
+            <a:ext cx="5047488" cy="2423160"/>
           </a:xfrm>
           <a:prstGeom prst="roundRect">
             <a:avLst>
@@ -5216,8 +6333,8 @@
         </p:nvSpPr>
         <p:spPr>
           <a:xfrm>
-            <a:off x="6208776" y="3621024"/>
-            <a:ext cx="4572000" cy="274200"/>
+            <a:off x="6208776" y="2944368"/>
+            <a:ext cx="4572000" cy="402336"/>
           </a:xfrm>
           <a:prstGeom prst="rect">
             <a:avLst/>
@@ -5248,7 +6365,7 @@
               <a:buNone/>
             </a:pPr>
             <a:r>
-              <a:rPr b="1" i="0" lang="en-US" sz="1250" u="none" cap="none" strike="noStrike">
+              <a:rPr b="1" i="0" lang="en-US" sz="2000" u="none" cap="none" strike="noStrike">
                 <a:solidFill>
                   <a:srgbClr val="B35C38"/>
                 </a:solidFill>
@@ -5257,7 +6374,7 @@
                 <a:cs typeface="Calibri"/>
                 <a:sym typeface="Calibri"/>
               </a:rPr>
-              <a:t>O QUE NÃO SUSTENTAMOS</a:t>
+              <a:t>TIRE A BUSCA HEURÍSTICA</a:t>
             </a:r>
             <a:endParaRPr b="0" i="0" sz="1250" u="none" cap="none" strike="noStrike">
               <a:solidFill>
@@ -5279,8 +6396,8 @@
         </p:nvSpPr>
         <p:spPr>
           <a:xfrm>
-            <a:off x="6208776" y="3950208"/>
-            <a:ext cx="4572000" cy="384000"/>
+            <a:off x="6208776" y="3401568"/>
+            <a:ext cx="4700016" cy="557784"/>
           </a:xfrm>
           <a:prstGeom prst="rect">
             <a:avLst/>
@@ -5314,7 +6431,7 @@
               <a:buNone/>
             </a:pPr>
             <a:r>
-              <a:rPr b="1" i="0" lang="en-US" sz="1700" u="none" cap="none" strike="noStrike">
+              <a:rPr b="1" i="0" lang="en-US" sz="3000" u="none" cap="none" strike="noStrike">
                 <a:solidFill>
                   <a:srgbClr val="33291F"/>
                 </a:solidFill>
@@ -5323,7 +6440,7 @@
                 <a:cs typeface="Cambria"/>
                 <a:sym typeface="Cambria"/>
               </a:rPr>
-              <a:t>Economia e exclusividade</a:t>
+              <a:t>O turno não cabe</a:t>
             </a:r>
             <a:endParaRPr b="0" i="0" sz="1700" u="none" cap="none" strike="noStrike">
               <a:solidFill>
@@ -5345,8 +6462,8 @@
         </p:nvSpPr>
         <p:spPr>
           <a:xfrm>
-            <a:off x="6208776" y="4407408"/>
-            <a:ext cx="4572000" cy="548700"/>
+            <a:off x="6208776" y="4023360"/>
+            <a:ext cx="4700016" cy="1143000"/>
           </a:xfrm>
           <a:prstGeom prst="rect">
             <a:avLst/>
@@ -5380,7 +6497,7 @@
               <a:buNone/>
             </a:pPr>
             <a:r>
-              <a:rPr b="0" i="0" lang="en-US" sz="1350" u="none" cap="none" strike="noStrike">
+              <a:rPr b="0" i="0" lang="en-US" sz="2200" u="none" cap="none" strike="noStrike">
                 <a:solidFill>
                   <a:srgbClr val="5C4F41"/>
                 </a:solidFill>
@@ -5389,7 +6506,7 @@
                 <a:cs typeface="Calibri"/>
                 <a:sym typeface="Calibri"/>
               </a:rPr>
-              <a:t>Não economiza deslocamento, e não encontra planos que um programa corrigido não encontraria.</a:t>
+              <a:t>Varrer o mesmo modelo sem heurística para em 5 ou 6 pacientes, e um turno real tem de 10 a 15.</a:t>
             </a:r>
             <a:endParaRPr b="0" i="0" sz="1350" u="none" cap="none" strike="noStrike">
               <a:solidFill>
@@ -5411,8 +6528,8 @@
         </p:nvSpPr>
         <p:spPr>
           <a:xfrm>
-            <a:off x="685800" y="5340096"/>
-            <a:ext cx="10820100" cy="548700"/>
+            <a:off x="685800" y="5349240"/>
+            <a:ext cx="10817352" cy="777240"/>
           </a:xfrm>
           <a:prstGeom prst="rect">
             <a:avLst/>
@@ -5446,7 +6563,7 @@
               <a:buNone/>
             </a:pPr>
             <a:r>
-              <a:rPr b="1" i="0" lang="en-US" sz="1700" u="none" cap="none" strike="noStrike">
+              <a:rPr b="1" i="0" lang="en-US" sz="2200" u="none" cap="none" strike="noStrike">
                 <a:solidFill>
                   <a:srgbClr val="33291F"/>
                 </a:solidFill>
@@ -5455,7 +6572,7 @@
                 <a:cs typeface="Cambria"/>
                 <a:sym typeface="Cambria"/>
               </a:rPr>
-              <a:t>A pergunta vira: o que mantém o sistema correto quando a norma muda, sem deixar de caber num turno real?</a:t>
+              <a:t>Nenhuma das duas metades sozinha resolve o problema. Planejamento Automatizado é o nome da combinação.</a:t>
             </a:r>
             <a:endParaRPr b="0" i="0" sz="1700" u="none" cap="none" strike="noStrike">
               <a:solidFill>
@@ -9904,6 +11021,1093 @@
   <p:cSld>
     <p:spTree>
       <p:nvGrpSpPr>
+        <p:cNvPr id="78" name="Shape 78"/>
+        <p:cNvGrpSpPr/>
+        <p:nvPr/>
+      </p:nvGrpSpPr>
+      <p:grpSpPr>
+        <a:xfrm>
+          <a:off x="0" y="0"/>
+          <a:ext cx="0" cy="0"/>
+          <a:chOff x="0" y="0"/>
+          <a:chExt cx="0" cy="0"/>
+        </a:xfrm>
+      </p:grpSpPr>
+      <p:sp>
+        <p:nvSpPr>
+          <p:cNvPr id="80" name="Google Shape;80;p9"/>
+          <p:cNvSpPr/>
+          <p:nvPr/>
+        </p:nvSpPr>
+        <p:spPr>
+          <a:xfrm>
+            <a:off x="685800" y="2724912"/>
+            <a:ext cx="3447288" cy="2834640"/>
+          </a:xfrm>
+          <a:prstGeom prst="roundRect">
+            <a:avLst>
+              <a:gd fmla="val 4132" name="adj"/>
+            </a:avLst>
+          </a:prstGeom>
+          <a:solidFill>
+            <a:srgbClr val="FFFDF8"/>
+          </a:solidFill>
+          <a:ln cap="flat" cmpd="sng" w="9525">
+            <a:solidFill>
+              <a:srgbClr val="E6DCCB"/>
+            </a:solidFill>
+            <a:prstDash val="solid"/>
+            <a:round/>
+            <a:headEnd len="sm" w="sm" type="none"/>
+            <a:tailEnd len="sm" w="sm" type="none"/>
+          </a:ln>
+          <a:effectLst>
+            <a:outerShdw blurRad="127000" rotWithShape="0" algn="bl" dir="5400000" dist="25400">
+              <a:srgbClr val="33291F">
+                <a:alpha val="10196"/>
+              </a:srgbClr>
+            </a:outerShdw>
+          </a:effectLst>
+        </p:spPr>
+        <p:txBody>
+          <a:bodyPr anchorCtr="0" anchor="ctr" bIns="91425" lIns="91425" spcFirstLastPara="1" rIns="91425" wrap="square" tIns="91425">
+            <a:noAutofit/>
+          </a:bodyPr>
+          <a:lstStyle/>
+          <a:p>
+            <a:pPr indent="0" lvl="0" marL="0" rtl="0" algn="just">
+              <a:spcBef>
+                <a:spcPts val="0"/>
+              </a:spcBef>
+              <a:spcAft>
+                <a:spcPts val="0"/>
+              </a:spcAft>
+              <a:buNone/>
+            </a:pPr>
+            <a:r>
+              <a:t/>
+            </a:r>
+            <a:endParaRPr/>
+          </a:p>
+        </p:txBody>
+      </p:sp>
+      <p:sp>
+        <p:nvSpPr>
+          <p:cNvPr id="81" name="Google Shape;81;p9"/>
+          <p:cNvSpPr txBox="1"/>
+          <p:nvPr/>
+        </p:nvSpPr>
+        <p:spPr>
+          <a:xfrm>
+            <a:off x="813816" y="3310128"/>
+            <a:ext cx="3191256" cy="960120"/>
+          </a:xfrm>
+          <a:prstGeom prst="rect">
+            <a:avLst/>
+          </a:prstGeom>
+          <a:noFill/>
+          <a:ln>
+            <a:noFill/>
+          </a:ln>
+        </p:spPr>
+        <p:txBody>
+          <a:bodyPr anchorCtr="0" anchor="ctr" bIns="0" lIns="0" spcFirstLastPara="1" rIns="0" wrap="square" tIns="0">
+            <a:noAutofit/>
+          </a:bodyPr>
+          <a:lstStyle/>
+          <a:p>
+            <a:pPr indent="0" lvl="0" marL="0" marR="0" rtl="0" algn="just">
+              <a:lnSpc>
+                <a:spcPct val="135483"/>
+              </a:lnSpc>
+              <a:spcBef>
+                <a:spcPts val="0"/>
+              </a:spcBef>
+              <a:spcAft>
+                <a:spcPts val="0"/>
+              </a:spcAft>
+              <a:buClr>
+                <a:srgbClr val="33291F"/>
+              </a:buClr>
+              <a:buSzPts val="1550"/>
+              <a:buFont typeface="Cambria"/>
+              <a:buNone/>
+            </a:pPr>
+            <a:r>
+              <a:rPr b="1" i="0" lang="en-US" sz="2800" u="none" cap="none" strike="noStrike">
+                <a:solidFill>
+                  <a:srgbClr val="33291F"/>
+                </a:solidFill>
+                <a:latin typeface="Cambria"/>
+                <a:ea typeface="Cambria"/>
+                <a:cs typeface="Cambria"/>
+                <a:sym typeface="Cambria"/>
+              </a:rPr>
+              <a:t>A norma vira domínio</a:t>
+            </a:r>
+            <a:endParaRPr b="0" i="0" sz="2150" u="none" cap="none" strike="noStrike">
+              <a:solidFill>
+                <a:schemeClr val="dk1"/>
+              </a:solidFill>
+              <a:latin typeface="Calibri"/>
+              <a:ea typeface="Calibri"/>
+              <a:cs typeface="Calibri"/>
+              <a:sym typeface="Calibri"/>
+            </a:endParaRPr>
+          </a:p>
+        </p:txBody>
+      </p:sp>
+      <p:sp>
+        <p:nvSpPr>
+          <p:cNvPr id="82" name="Google Shape;82;p9"/>
+          <p:cNvSpPr txBox="1"/>
+          <p:nvPr/>
+        </p:nvSpPr>
+        <p:spPr>
+          <a:xfrm>
+            <a:off x="813816" y="4334256"/>
+            <a:ext cx="3191256" cy="1207008"/>
+          </a:xfrm>
+          <a:prstGeom prst="rect">
+            <a:avLst/>
+          </a:prstGeom>
+          <a:noFill/>
+          <a:ln>
+            <a:noFill/>
+          </a:ln>
+        </p:spPr>
+        <p:txBody>
+          <a:bodyPr anchorCtr="0" anchor="t" bIns="0" lIns="0" spcFirstLastPara="1" rIns="0" wrap="square" tIns="0">
+            <a:noAutofit/>
+          </a:bodyPr>
+          <a:lstStyle/>
+          <a:p>
+            <a:pPr indent="0" lvl="0" marL="0" marR="0" rtl="0" algn="just">
+              <a:lnSpc>
+                <a:spcPct val="120000"/>
+              </a:lnSpc>
+              <a:spcBef>
+                <a:spcPts val="0"/>
+              </a:spcBef>
+              <a:spcAft>
+                <a:spcPts val="0"/>
+              </a:spcAft>
+              <a:buClr>
+                <a:srgbClr val="5C4F41"/>
+              </a:buClr>
+              <a:buSzPts val="1250"/>
+              <a:buFont typeface="Calibri"/>
+              <a:buNone/>
+            </a:pPr>
+            <a:r>
+              <a:rPr b="0" i="0" lang="en-US" sz="1800" u="none" cap="none" strike="noStrike">
+                <a:solidFill>
+                  <a:srgbClr val="5C4F41"/>
+                </a:solidFill>
+                <a:latin typeface="Calibri"/>
+                <a:ea typeface="Calibri"/>
+                <a:cs typeface="Calibri"/>
+                <a:sym typeface="Calibri"/>
+              </a:rPr>
+              <a:t>Os §§ 3º e 4º do art. 3º da Lei 11.350/2006 e as diretrizes da PNAB em ações, pré-condições e efeitos.</a:t>
+            </a:r>
+            <a:endParaRPr b="0" i="0" sz="1950" u="none" cap="none" strike="noStrike">
+              <a:solidFill>
+                <a:schemeClr val="dk1"/>
+              </a:solidFill>
+              <a:latin typeface="Calibri"/>
+              <a:ea typeface="Calibri"/>
+              <a:cs typeface="Calibri"/>
+              <a:sym typeface="Calibri"/>
+            </a:endParaRPr>
+          </a:p>
+        </p:txBody>
+      </p:sp>
+      <p:sp>
+        <p:nvSpPr>
+          <p:cNvPr id="83" name="Google Shape;83;p9"/>
+          <p:cNvSpPr/>
+          <p:nvPr/>
+        </p:nvSpPr>
+        <p:spPr>
+          <a:xfrm>
+            <a:off x="4370832" y="2724912"/>
+            <a:ext cx="3447288" cy="2834640"/>
+          </a:xfrm>
+          <a:prstGeom prst="roundRect">
+            <a:avLst>
+              <a:gd fmla="val 4132" name="adj"/>
+            </a:avLst>
+          </a:prstGeom>
+          <a:solidFill>
+            <a:srgbClr val="FFFDF8"/>
+          </a:solidFill>
+          <a:ln cap="flat" cmpd="sng" w="9525">
+            <a:solidFill>
+              <a:srgbClr val="E6DCCB"/>
+            </a:solidFill>
+            <a:prstDash val="solid"/>
+            <a:round/>
+            <a:headEnd len="sm" w="sm" type="none"/>
+            <a:tailEnd len="sm" w="sm" type="none"/>
+          </a:ln>
+          <a:effectLst>
+            <a:outerShdw blurRad="127000" rotWithShape="0" algn="bl" dir="5400000" dist="25400">
+              <a:srgbClr val="33291F">
+                <a:alpha val="10196"/>
+              </a:srgbClr>
+            </a:outerShdw>
+          </a:effectLst>
+        </p:spPr>
+        <p:txBody>
+          <a:bodyPr anchorCtr="0" anchor="ctr" bIns="91425" lIns="91425" spcFirstLastPara="1" rIns="91425" wrap="square" tIns="91425">
+            <a:noAutofit/>
+          </a:bodyPr>
+          <a:lstStyle/>
+          <a:p>
+            <a:pPr indent="0" lvl="0" marL="0" rtl="0" algn="just">
+              <a:spcBef>
+                <a:spcPts val="0"/>
+              </a:spcBef>
+              <a:spcAft>
+                <a:spcPts val="0"/>
+              </a:spcAft>
+              <a:buNone/>
+            </a:pPr>
+            <a:r>
+              <a:t/>
+            </a:r>
+            <a:endParaRPr/>
+          </a:p>
+        </p:txBody>
+      </p:sp>
+      <p:sp>
+        <p:nvSpPr>
+          <p:cNvPr id="84" name="Google Shape;84;p9"/>
+          <p:cNvSpPr txBox="1"/>
+          <p:nvPr/>
+        </p:nvSpPr>
+        <p:spPr>
+          <a:xfrm>
+            <a:off x="4498848" y="3310128"/>
+            <a:ext cx="3191256" cy="960120"/>
+          </a:xfrm>
+          <a:prstGeom prst="rect">
+            <a:avLst/>
+          </a:prstGeom>
+          <a:noFill/>
+          <a:ln>
+            <a:noFill/>
+          </a:ln>
+        </p:spPr>
+        <p:txBody>
+          <a:bodyPr anchorCtr="0" anchor="ctr" bIns="0" lIns="0" spcFirstLastPara="1" rIns="0" wrap="square" tIns="0">
+            <a:noAutofit/>
+          </a:bodyPr>
+          <a:lstStyle/>
+          <a:p>
+            <a:pPr indent="0" lvl="0" marL="0" marR="0" rtl="0" algn="just">
+              <a:lnSpc>
+                <a:spcPct val="135483"/>
+              </a:lnSpc>
+              <a:spcBef>
+                <a:spcPts val="0"/>
+              </a:spcBef>
+              <a:spcAft>
+                <a:spcPts val="0"/>
+              </a:spcAft>
+              <a:buClr>
+                <a:srgbClr val="33291F"/>
+              </a:buClr>
+              <a:buSzPts val="1550"/>
+              <a:buFont typeface="Cambria"/>
+              <a:buNone/>
+            </a:pPr>
+            <a:r>
+              <a:rPr b="1" i="0" lang="en-US" sz="2800" u="none" cap="none" strike="noStrike">
+                <a:solidFill>
+                  <a:srgbClr val="33291F"/>
+                </a:solidFill>
+                <a:latin typeface="Cambria"/>
+                <a:ea typeface="Cambria"/>
+                <a:cs typeface="Cambria"/>
+                <a:sym typeface="Cambria"/>
+              </a:rPr>
+              <a:t>O sistema em três camadas</a:t>
+            </a:r>
+            <a:endParaRPr b="0" i="0" sz="2150" u="none" cap="none" strike="noStrike">
+              <a:solidFill>
+                <a:schemeClr val="dk1"/>
+              </a:solidFill>
+              <a:latin typeface="Calibri"/>
+              <a:ea typeface="Calibri"/>
+              <a:cs typeface="Calibri"/>
+              <a:sym typeface="Calibri"/>
+            </a:endParaRPr>
+          </a:p>
+        </p:txBody>
+      </p:sp>
+      <p:sp>
+        <p:nvSpPr>
+          <p:cNvPr id="85" name="Google Shape;85;p9"/>
+          <p:cNvSpPr txBox="1"/>
+          <p:nvPr/>
+        </p:nvSpPr>
+        <p:spPr>
+          <a:xfrm>
+            <a:off x="4498848" y="4334256"/>
+            <a:ext cx="3191256" cy="1207008"/>
+          </a:xfrm>
+          <a:prstGeom prst="rect">
+            <a:avLst/>
+          </a:prstGeom>
+          <a:noFill/>
+          <a:ln>
+            <a:noFill/>
+          </a:ln>
+        </p:spPr>
+        <p:txBody>
+          <a:bodyPr anchorCtr="0" anchor="t" bIns="0" lIns="0" spcFirstLastPara="1" rIns="0" wrap="square" tIns="0">
+            <a:noAutofit/>
+          </a:bodyPr>
+          <a:lstStyle/>
+          <a:p>
+            <a:pPr indent="0" lvl="0" marL="0" marR="0" rtl="0" algn="just">
+              <a:lnSpc>
+                <a:spcPct val="120000"/>
+              </a:lnSpc>
+              <a:spcBef>
+                <a:spcPts val="0"/>
+              </a:spcBef>
+              <a:spcAft>
+                <a:spcPts val="0"/>
+              </a:spcAft>
+              <a:buClr>
+                <a:srgbClr val="5C4F41"/>
+              </a:buClr>
+              <a:buSzPts val="1250"/>
+              <a:buFont typeface="Calibri"/>
+              <a:buNone/>
+            </a:pPr>
+            <a:r>
+              <a:rPr b="0" i="0" lang="en-US" sz="1800" u="none" cap="none" strike="noStrike">
+                <a:solidFill>
+                  <a:srgbClr val="5C4F41"/>
+                </a:solidFill>
+                <a:latin typeface="Calibri"/>
+                <a:ea typeface="Calibri"/>
+                <a:cs typeface="Calibri"/>
+                <a:sym typeface="Calibri"/>
+              </a:rPr>
+              <a:t>Roteirização, tradução para PDDL, planejador, executor procedural de referência e roteiro legível.</a:t>
+            </a:r>
+            <a:endParaRPr b="0" i="0" sz="1950" u="none" cap="none" strike="noStrike">
+              <a:solidFill>
+                <a:schemeClr val="dk1"/>
+              </a:solidFill>
+              <a:latin typeface="Calibri"/>
+              <a:ea typeface="Calibri"/>
+              <a:cs typeface="Calibri"/>
+              <a:sym typeface="Calibri"/>
+            </a:endParaRPr>
+          </a:p>
+        </p:txBody>
+      </p:sp>
+      <p:sp>
+        <p:nvSpPr>
+          <p:cNvPr id="86" name="Google Shape;86;p9"/>
+          <p:cNvSpPr/>
+          <p:nvPr/>
+        </p:nvSpPr>
+        <p:spPr>
+          <a:xfrm>
+            <a:off x="8055864" y="2724912"/>
+            <a:ext cx="3447288" cy="2834640"/>
+          </a:xfrm>
+          <a:prstGeom prst="roundRect">
+            <a:avLst>
+              <a:gd fmla="val 4132" name="adj"/>
+            </a:avLst>
+          </a:prstGeom>
+          <a:solidFill>
+            <a:srgbClr val="FFFDF8"/>
+          </a:solidFill>
+          <a:ln cap="flat" cmpd="sng" w="9525">
+            <a:solidFill>
+              <a:srgbClr val="E6DCCB"/>
+            </a:solidFill>
+            <a:prstDash val="solid"/>
+            <a:round/>
+            <a:headEnd len="sm" w="sm" type="none"/>
+            <a:tailEnd len="sm" w="sm" type="none"/>
+          </a:ln>
+          <a:effectLst>
+            <a:outerShdw blurRad="127000" rotWithShape="0" algn="bl" dir="5400000" dist="25400">
+              <a:srgbClr val="33291F">
+                <a:alpha val="10196"/>
+              </a:srgbClr>
+            </a:outerShdw>
+          </a:effectLst>
+        </p:spPr>
+        <p:txBody>
+          <a:bodyPr anchorCtr="0" anchor="ctr" bIns="91425" lIns="91425" spcFirstLastPara="1" rIns="91425" wrap="square" tIns="91425">
+            <a:noAutofit/>
+          </a:bodyPr>
+          <a:lstStyle/>
+          <a:p>
+            <a:pPr indent="0" lvl="0" marL="0" rtl="0" algn="just">
+              <a:spcBef>
+                <a:spcPts val="0"/>
+              </a:spcBef>
+              <a:spcAft>
+                <a:spcPts val="0"/>
+              </a:spcAft>
+              <a:buNone/>
+            </a:pPr>
+            <a:r>
+              <a:t/>
+            </a:r>
+            <a:endParaRPr/>
+          </a:p>
+        </p:txBody>
+      </p:sp>
+      <p:sp>
+        <p:nvSpPr>
+          <p:cNvPr id="87" name="Google Shape;87;p9"/>
+          <p:cNvSpPr txBox="1"/>
+          <p:nvPr/>
+        </p:nvSpPr>
+        <p:spPr>
+          <a:xfrm>
+            <a:off x="8183880" y="3310128"/>
+            <a:ext cx="3191256" cy="960120"/>
+          </a:xfrm>
+          <a:prstGeom prst="rect">
+            <a:avLst/>
+          </a:prstGeom>
+          <a:noFill/>
+          <a:ln>
+            <a:noFill/>
+          </a:ln>
+        </p:spPr>
+        <p:txBody>
+          <a:bodyPr anchorCtr="0" anchor="ctr" bIns="0" lIns="0" spcFirstLastPara="1" rIns="0" wrap="square" tIns="0">
+            <a:noAutofit/>
+          </a:bodyPr>
+          <a:lstStyle/>
+          <a:p>
+            <a:pPr indent="0" lvl="0" marL="0" marR="0" rtl="0" algn="just">
+              <a:lnSpc>
+                <a:spcPct val="135483"/>
+              </a:lnSpc>
+              <a:spcBef>
+                <a:spcPts val="0"/>
+              </a:spcBef>
+              <a:spcAft>
+                <a:spcPts val="0"/>
+              </a:spcAft>
+              <a:buClr>
+                <a:srgbClr val="33291F"/>
+              </a:buClr>
+              <a:buSzPts val="1550"/>
+              <a:buFont typeface="Cambria"/>
+              <a:buNone/>
+            </a:pPr>
+            <a:r>
+              <a:rPr b="1" i="0" lang="en-US" sz="2800" u="none" cap="none" strike="noStrike">
+                <a:solidFill>
+                  <a:srgbClr val="33291F"/>
+                </a:solidFill>
+                <a:latin typeface="Cambria"/>
+                <a:ea typeface="Cambria"/>
+                <a:cs typeface="Cambria"/>
+                <a:sym typeface="Cambria"/>
+              </a:rPr>
+              <a:t>A comparação medida</a:t>
+            </a:r>
+            <a:endParaRPr b="0" i="0" sz="2150" u="none" cap="none" strike="noStrike">
+              <a:solidFill>
+                <a:schemeClr val="dk1"/>
+              </a:solidFill>
+              <a:latin typeface="Calibri"/>
+              <a:ea typeface="Calibri"/>
+              <a:cs typeface="Calibri"/>
+              <a:sym typeface="Calibri"/>
+            </a:endParaRPr>
+          </a:p>
+        </p:txBody>
+      </p:sp>
+      <p:sp>
+        <p:nvSpPr>
+          <p:cNvPr id="88" name="Google Shape;88;p9"/>
+          <p:cNvSpPr txBox="1"/>
+          <p:nvPr/>
+        </p:nvSpPr>
+        <p:spPr>
+          <a:xfrm>
+            <a:off x="8183880" y="4334256"/>
+            <a:ext cx="3191256" cy="1207008"/>
+          </a:xfrm>
+          <a:prstGeom prst="rect">
+            <a:avLst/>
+          </a:prstGeom>
+          <a:noFill/>
+          <a:ln>
+            <a:noFill/>
+          </a:ln>
+        </p:spPr>
+        <p:txBody>
+          <a:bodyPr anchorCtr="0" anchor="t" bIns="0" lIns="0" spcFirstLastPara="1" rIns="0" wrap="square" tIns="0">
+            <a:noAutofit/>
+          </a:bodyPr>
+          <a:lstStyle/>
+          <a:p>
+            <a:pPr indent="0" lvl="0" marL="0" marR="0" rtl="0" algn="just">
+              <a:lnSpc>
+                <a:spcPct val="120000"/>
+              </a:lnSpc>
+              <a:spcBef>
+                <a:spcPts val="0"/>
+              </a:spcBef>
+              <a:spcAft>
+                <a:spcPts val="0"/>
+              </a:spcAft>
+              <a:buClr>
+                <a:srgbClr val="5C4F41"/>
+              </a:buClr>
+              <a:buSzPts val="1250"/>
+              <a:buFont typeface="Calibri"/>
+              <a:buNone/>
+            </a:pPr>
+            <a:r>
+              <a:rPr b="0" i="0" lang="en-US" sz="1800" u="none" cap="none" strike="noStrike">
+                <a:solidFill>
+                  <a:srgbClr val="5C4F41"/>
+                </a:solidFill>
+                <a:latin typeface="Calibri"/>
+                <a:ea typeface="Calibri"/>
+                <a:cs typeface="Calibri"/>
+                <a:sym typeface="Calibri"/>
+              </a:rPr>
+              <a:t>Experimentos controlados de escalabilidade, qualidade do plano e reconhecimento de inviabilidade.</a:t>
+            </a:r>
+            <a:endParaRPr b="0" i="0" sz="2250" u="none" cap="none" strike="noStrike">
+              <a:solidFill>
+                <a:schemeClr val="dk1"/>
+              </a:solidFill>
+              <a:latin typeface="Calibri"/>
+              <a:ea typeface="Calibri"/>
+              <a:cs typeface="Calibri"/>
+              <a:sym typeface="Calibri"/>
+            </a:endParaRPr>
+          </a:p>
+        </p:txBody>
+      </p:sp>
+      <p:sp>
+        <p:nvSpPr>
+          <p:cNvPr id="89" name="Google Shape;89;p9"/>
+          <p:cNvSpPr/>
+          <p:nvPr/>
+        </p:nvSpPr>
+        <p:spPr>
+          <a:xfrm>
+            <a:off x="685800" y="1152144"/>
+            <a:ext cx="10817352" cy="1463040"/>
+          </a:xfrm>
+          <a:prstGeom prst="roundRect">
+            <a:avLst>
+              <a:gd fmla="val 11538" name="adj"/>
+            </a:avLst>
+          </a:prstGeom>
+          <a:solidFill>
+            <a:srgbClr val="DDE7E0"/>
+          </a:solidFill>
+          <a:ln>
+            <a:noFill/>
+          </a:ln>
+        </p:spPr>
+        <p:txBody>
+          <a:bodyPr anchorCtr="0" anchor="ctr" bIns="91425" lIns="91425" spcFirstLastPara="1" rIns="91425" wrap="square" tIns="91425">
+            <a:noAutofit/>
+          </a:bodyPr>
+          <a:lstStyle/>
+          <a:p>
+            <a:pPr indent="0" lvl="0" marL="0" rtl="0" algn="just">
+              <a:spcBef>
+                <a:spcPts val="0"/>
+              </a:spcBef>
+              <a:spcAft>
+                <a:spcPts val="0"/>
+              </a:spcAft>
+              <a:buNone/>
+            </a:pPr>
+            <a:r>
+              <a:t/>
+            </a:r>
+            <a:endParaRPr/>
+          </a:p>
+        </p:txBody>
+      </p:sp>
+      <p:sp>
+        <p:nvSpPr>
+          <p:cNvPr id="90" name="Google Shape;90;p9"/>
+          <p:cNvSpPr txBox="1"/>
+          <p:nvPr/>
+        </p:nvSpPr>
+        <p:spPr>
+          <a:xfrm>
+            <a:off x="960120" y="1225296"/>
+            <a:ext cx="10268712" cy="1298448"/>
+          </a:xfrm>
+          <a:prstGeom prst="rect">
+            <a:avLst/>
+          </a:prstGeom>
+          <a:noFill/>
+          <a:ln>
+            <a:noFill/>
+          </a:ln>
+        </p:spPr>
+        <p:txBody>
+          <a:bodyPr anchorCtr="0" anchor="ctr" bIns="0" lIns="0" spcFirstLastPara="1" rIns="0" wrap="square" tIns="0">
+            <a:noAutofit/>
+          </a:bodyPr>
+          <a:lstStyle/>
+          <a:p>
+            <a:pPr indent="0" lvl="0" marL="0" marR="0" rtl="0" algn="just">
+              <a:lnSpc>
+                <a:spcPct val="122580"/>
+              </a:lnSpc>
+              <a:spcBef>
+                <a:spcPts val="0"/>
+              </a:spcBef>
+              <a:spcAft>
+                <a:spcPts val="0"/>
+              </a:spcAft>
+              <a:buClr>
+                <a:srgbClr val="33291F"/>
+              </a:buClr>
+              <a:buSzPts val="1550"/>
+              <a:buFont typeface="Cambria"/>
+              <a:buNone/>
+            </a:pPr>
+            <a:r>
+              <a:rPr b="0" i="1" lang="en-US" sz="2600" u="none" cap="none" strike="noStrike">
+                <a:solidFill>
+                  <a:srgbClr val="33291F"/>
+                </a:solidFill>
+                <a:latin typeface="Cambria"/>
+                <a:ea typeface="Cambria"/>
+                <a:cs typeface="Cambria"/>
+                <a:sym typeface="Cambria"/>
+              </a:rPr>
+              <a:t>Modelar, implementar e validar um sistema que decide as ações e os desvios de reposição de um turno de visitas, e medir onde esse paradigma supera um executor procedural equivalente.</a:t>
+            </a:r>
+            <a:endParaRPr b="0" i="0" sz="2650" u="none" cap="none" strike="noStrike">
+              <a:solidFill>
+                <a:schemeClr val="dk1"/>
+              </a:solidFill>
+              <a:latin typeface="Calibri"/>
+              <a:ea typeface="Calibri"/>
+              <a:cs typeface="Calibri"/>
+              <a:sym typeface="Calibri"/>
+            </a:endParaRPr>
+          </a:p>
+        </p:txBody>
+      </p:sp>
+      <p:sp>
+        <p:nvSpPr>
+          <p:cNvPr id="91" name="Google Shape;91;p9"/>
+          <p:cNvSpPr txBox="1"/>
+          <p:nvPr>
+            <p:ph idx="4294967295" type="sldNum"/>
+          </p:nvPr>
+        </p:nvSpPr>
+        <p:spPr>
+          <a:xfrm>
+            <a:off x="11384280" y="6327648"/>
+            <a:ext cx="365760" cy="274320"/>
+          </a:xfrm>
+          <a:prstGeom prst="rect">
+            <a:avLst/>
+          </a:prstGeom>
+          <a:noFill/>
+          <a:ln>
+            <a:noFill/>
+          </a:ln>
+        </p:spPr>
+        <p:txBody>
+          <a:bodyPr anchorCtr="0" anchor="t" bIns="45700" lIns="91425" spcFirstLastPara="1" rIns="91425" wrap="square" tIns="45700">
+            <a:noAutofit/>
+          </a:bodyPr>
+          <a:lstStyle/>
+          <a:p>
+            <a:pPr indent="0" lvl="0" marL="0" marR="0" rtl="0" algn="just">
+              <a:spcBef>
+                <a:spcPts val="0"/>
+              </a:spcBef>
+              <a:spcAft>
+                <a:spcPts val="0"/>
+              </a:spcAft>
+              <a:buNone/>
+            </a:pPr>
+            <a:fld id="{00000000-1234-1234-1234-123412341234}" type="slidenum">
+              <a:rPr b="0" i="0" lang="en-US" sz="1000" u="none" cap="none" strike="noStrike">
+                <a:solidFill>
+                  <a:srgbClr val="8A7A67"/>
+                </a:solidFill>
+                <a:latin typeface="Calibri"/>
+                <a:ea typeface="Calibri"/>
+                <a:cs typeface="Calibri"/>
+                <a:sym typeface="Calibri"/>
+              </a:rPr>
+              <a:t>‹#›</a:t>
+            </a:fld>
+            <a:endParaRPr b="0" i="0" sz="1000" u="none" cap="none" strike="noStrike">
+              <a:solidFill>
+                <a:srgbClr val="8A7A67"/>
+              </a:solidFill>
+              <a:latin typeface="Calibri"/>
+              <a:ea typeface="Calibri"/>
+              <a:cs typeface="Calibri"/>
+              <a:sym typeface="Calibri"/>
+            </a:endParaRPr>
+          </a:p>
+        </p:txBody>
+      </p:sp>
+      <p:sp>
+        <p:nvSpPr>
+          <p:cNvPr id="92" name="Google Shape;92;p9"/>
+          <p:cNvSpPr txBox="1"/>
+          <p:nvPr/>
+        </p:nvSpPr>
+        <p:spPr>
+          <a:xfrm>
+            <a:off x="411475" y="304883"/>
+            <a:ext cx="10820100" cy="868800"/>
+          </a:xfrm>
+          <a:prstGeom prst="rect">
+            <a:avLst/>
+          </a:prstGeom>
+          <a:noFill/>
+          <a:ln>
+            <a:noFill/>
+          </a:ln>
+        </p:spPr>
+        <p:txBody>
+          <a:bodyPr anchorCtr="0" anchor="t" bIns="0" lIns="0" spcFirstLastPara="1" rIns="0" wrap="square" tIns="0">
+            <a:noAutofit/>
+          </a:bodyPr>
+          <a:lstStyle/>
+          <a:p>
+            <a:pPr indent="0" lvl="0" marL="0" marR="0" rtl="0" algn="just">
+              <a:lnSpc>
+                <a:spcPct val="111764"/>
+              </a:lnSpc>
+              <a:spcBef>
+                <a:spcPts val="0"/>
+              </a:spcBef>
+              <a:spcAft>
+                <a:spcPts val="0"/>
+              </a:spcAft>
+              <a:buClr>
+                <a:srgbClr val="33291F"/>
+              </a:buClr>
+              <a:buSzPts val="3400"/>
+              <a:buFont typeface="Cambria"/>
+              <a:buNone/>
+            </a:pPr>
+            <a:r>
+              <a:rPr b="1" lang="en-US" sz="4800">
+                <a:solidFill>
+                  <a:srgbClr val="33291F"/>
+                </a:solidFill>
+                <a:latin typeface="Cambria"/>
+                <a:ea typeface="Cambria"/>
+                <a:cs typeface="Cambria"/>
+                <a:sym typeface="Cambria"/>
+              </a:rPr>
+              <a:t>OBJETIVOS</a:t>
+            </a:r>
+            <a:endParaRPr b="1" sz="4800">
+              <a:solidFill>
+                <a:srgbClr val="33291F"/>
+              </a:solidFill>
+              <a:latin typeface="Cambria"/>
+              <a:ea typeface="Cambria"/>
+              <a:cs typeface="Cambria"/>
+              <a:sym typeface="Cambria"/>
+            </a:endParaRPr>
+          </a:p>
+        </p:txBody>
+      </p:sp>
+      <p:sp>
+        <p:nvSpPr>
+          <p:cNvPr id="201" name="Google Shape;201;novo"/>
+          <p:cNvSpPr txBox="1"/>
+          <p:nvPr/>
+        </p:nvSpPr>
+        <p:spPr>
+          <a:xfrm>
+            <a:off x="813816" y="2852928"/>
+            <a:ext cx="3191256" cy="402336"/>
+          </a:xfrm>
+          <a:prstGeom prst="rect">
+            <a:avLst/>
+          </a:prstGeom>
+          <a:noFill/>
+          <a:ln>
+            <a:noFill/>
+          </a:ln>
+        </p:spPr>
+        <p:txBody>
+          <a:bodyPr anchorCtr="0" anchor="ctr" bIns="0" lIns="0" spcFirstLastPara="1" rIns="0" wrap="square" tIns="0">
+            <a:noAutofit/>
+          </a:bodyPr>
+          <a:lstStyle/>
+          <a:p>
+            <a:pPr indent="0" lvl="0" marL="0" marR="0" rtl="0" algn="just">
+              <a:spcBef>
+                <a:spcPts val="0"/>
+              </a:spcBef>
+              <a:spcAft>
+                <a:spcPts val="0"/>
+              </a:spcAft>
+              <a:buClr>
+                <a:srgbClr val="B35C38"/>
+              </a:buClr>
+              <a:buSzPts val="1250"/>
+              <a:buFont typeface="Calibri"/>
+              <a:buNone/>
+            </a:pPr>
+            <a:r>
+              <a:rPr b="1" i="0" lang="en-US" sz="2000" u="none" cap="none" strike="noStrike">
+                <a:solidFill>
+                  <a:srgbClr val="B35C38"/>
+                </a:solidFill>
+                <a:latin typeface="Calibri"/>
+                <a:ea typeface="Calibri"/>
+                <a:cs typeface="Calibri"/>
+                <a:sym typeface="Calibri"/>
+              </a:rPr>
+              <a:t>1. FORMALIZAR</a:t>
+            </a:r>
+            <a:endParaRPr b="0" i="0" sz="2050" u="none" cap="none" strike="noStrike">
+              <a:solidFill>
+                <a:schemeClr val="dk1"/>
+              </a:solidFill>
+              <a:latin typeface="Calibri"/>
+              <a:ea typeface="Calibri"/>
+              <a:cs typeface="Calibri"/>
+              <a:sym typeface="Calibri"/>
+            </a:endParaRPr>
+          </a:p>
+        </p:txBody>
+      </p:sp>
+      <p:sp>
+        <p:nvSpPr>
+          <p:cNvPr id="202" name="Google Shape;202;novo"/>
+          <p:cNvSpPr txBox="1"/>
+          <p:nvPr/>
+        </p:nvSpPr>
+        <p:spPr>
+          <a:xfrm>
+            <a:off x="4498848" y="2852928"/>
+            <a:ext cx="3191256" cy="402336"/>
+          </a:xfrm>
+          <a:prstGeom prst="rect">
+            <a:avLst/>
+          </a:prstGeom>
+          <a:noFill/>
+          <a:ln>
+            <a:noFill/>
+          </a:ln>
+        </p:spPr>
+        <p:txBody>
+          <a:bodyPr anchorCtr="0" anchor="ctr" bIns="0" lIns="0" spcFirstLastPara="1" rIns="0" wrap="square" tIns="0">
+            <a:noAutofit/>
+          </a:bodyPr>
+          <a:lstStyle/>
+          <a:p>
+            <a:pPr indent="0" lvl="0" marL="0" marR="0" rtl="0" algn="just">
+              <a:spcBef>
+                <a:spcPts val="0"/>
+              </a:spcBef>
+              <a:spcAft>
+                <a:spcPts val="0"/>
+              </a:spcAft>
+              <a:buClr>
+                <a:srgbClr val="B35C38"/>
+              </a:buClr>
+              <a:buSzPts val="1250"/>
+              <a:buFont typeface="Calibri"/>
+              <a:buNone/>
+            </a:pPr>
+            <a:r>
+              <a:rPr b="1" i="0" lang="en-US" sz="2000" u="none" cap="none" strike="noStrike">
+                <a:solidFill>
+                  <a:srgbClr val="B35C38"/>
+                </a:solidFill>
+                <a:latin typeface="Calibri"/>
+                <a:ea typeface="Calibri"/>
+                <a:cs typeface="Calibri"/>
+                <a:sym typeface="Calibri"/>
+              </a:rPr>
+              <a:t>2. CONSTRUIR</a:t>
+            </a:r>
+            <a:endParaRPr b="0" i="0" sz="2050" u="none" cap="none" strike="noStrike">
+              <a:solidFill>
+                <a:schemeClr val="dk1"/>
+              </a:solidFill>
+              <a:latin typeface="Calibri"/>
+              <a:ea typeface="Calibri"/>
+              <a:cs typeface="Calibri"/>
+              <a:sym typeface="Calibri"/>
+            </a:endParaRPr>
+          </a:p>
+        </p:txBody>
+      </p:sp>
+      <p:sp>
+        <p:nvSpPr>
+          <p:cNvPr id="203" name="Google Shape;203;novo"/>
+          <p:cNvSpPr txBox="1"/>
+          <p:nvPr/>
+        </p:nvSpPr>
+        <p:spPr>
+          <a:xfrm>
+            <a:off x="8183880" y="2852928"/>
+            <a:ext cx="3191256" cy="402336"/>
+          </a:xfrm>
+          <a:prstGeom prst="rect">
+            <a:avLst/>
+          </a:prstGeom>
+          <a:noFill/>
+          <a:ln>
+            <a:noFill/>
+          </a:ln>
+        </p:spPr>
+        <p:txBody>
+          <a:bodyPr anchorCtr="0" anchor="ctr" bIns="0" lIns="0" spcFirstLastPara="1" rIns="0" wrap="square" tIns="0">
+            <a:noAutofit/>
+          </a:bodyPr>
+          <a:lstStyle/>
+          <a:p>
+            <a:pPr indent="0" lvl="0" marL="0" marR="0" rtl="0" algn="just">
+              <a:spcBef>
+                <a:spcPts val="0"/>
+              </a:spcBef>
+              <a:spcAft>
+                <a:spcPts val="0"/>
+              </a:spcAft>
+              <a:buClr>
+                <a:srgbClr val="B35C38"/>
+              </a:buClr>
+              <a:buSzPts val="1250"/>
+              <a:buFont typeface="Calibri"/>
+              <a:buNone/>
+            </a:pPr>
+            <a:r>
+              <a:rPr b="1" i="0" lang="en-US" sz="2000" u="none" cap="none" strike="noStrike">
+                <a:solidFill>
+                  <a:srgbClr val="B35C38"/>
+                </a:solidFill>
+                <a:latin typeface="Calibri"/>
+                <a:ea typeface="Calibri"/>
+                <a:cs typeface="Calibri"/>
+                <a:sym typeface="Calibri"/>
+              </a:rPr>
+              <a:t>3. VALIDAR</a:t>
+            </a:r>
+            <a:endParaRPr b="0" i="0" sz="2050" u="none" cap="none" strike="noStrike">
+              <a:solidFill>
+                <a:schemeClr val="dk1"/>
+              </a:solidFill>
+              <a:latin typeface="Calibri"/>
+              <a:ea typeface="Calibri"/>
+              <a:cs typeface="Calibri"/>
+              <a:sym typeface="Calibri"/>
+            </a:endParaRPr>
+          </a:p>
+        </p:txBody>
+      </p:sp>
+      <p:sp>
+        <p:nvSpPr>
+          <p:cNvPr id="210" name="Google Shape;210;novo"/>
+          <p:cNvSpPr txBox="1"/>
+          <p:nvPr/>
+        </p:nvSpPr>
+        <p:spPr>
+          <a:xfrm>
+            <a:off x="685800" y="5687568"/>
+            <a:ext cx="10817352" cy="457200"/>
+          </a:xfrm>
+          <a:prstGeom prst="rect">
+            <a:avLst/>
+          </a:prstGeom>
+          <a:noFill/>
+          <a:ln>
+            <a:noFill/>
+          </a:ln>
+        </p:spPr>
+        <p:txBody>
+          <a:bodyPr anchorCtr="0" anchor="ctr" bIns="0" lIns="0" spcFirstLastPara="1" rIns="0" wrap="square" tIns="0">
+            <a:noAutofit/>
+          </a:bodyPr>
+          <a:lstStyle/>
+          <a:p>
+            <a:pPr indent="0" lvl="0" marL="0" marR="0" rtl="0" algn="just">
+              <a:lnSpc>
+                <a:spcPct val="122580"/>
+              </a:lnSpc>
+              <a:spcBef>
+                <a:spcPts val="0"/>
+              </a:spcBef>
+              <a:spcAft>
+                <a:spcPts val="0"/>
+              </a:spcAft>
+              <a:buClr>
+                <a:srgbClr val="33291F"/>
+              </a:buClr>
+              <a:buSzPts val="1550"/>
+              <a:buFont typeface="Cambria"/>
+              <a:buNone/>
+            </a:pPr>
+            <a:r>
+              <a:rPr b="0" i="1" lang="en-US" sz="2200" u="none" cap="none" strike="noStrike">
+                <a:solidFill>
+                  <a:srgbClr val="33291F"/>
+                </a:solidFill>
+                <a:latin typeface="Cambria"/>
+                <a:ea typeface="Cambria"/>
+                <a:cs typeface="Cambria"/>
+                <a:sym typeface="Cambria"/>
+              </a:rPr>
+              <a:t>Três verbos, seis objetivos, e a ordem entre eles é a ordem do trabalho.</a:t>
+            </a:r>
+            <a:endParaRPr b="0" i="0" sz="2650" u="none" cap="none" strike="noStrike">
+              <a:solidFill>
+                <a:schemeClr val="dk1"/>
+              </a:solidFill>
+              <a:latin typeface="Calibri"/>
+              <a:ea typeface="Calibri"/>
+              <a:cs typeface="Calibri"/>
+              <a:sym typeface="Calibri"/>
+            </a:endParaRPr>
+          </a:p>
+        </p:txBody>
+      </p:sp>
+    </p:spTree>
+  </p:cSld>
+  <p:clrMapOvr>
+    <a:masterClrMapping/>
+  </p:clrMapOvr>
+</p:sld>
+</file>
+
+<file path=ppt/slides/slide8.xml><?xml version="1.0" encoding="utf-8"?>
+<p:sld xmlns:a="http://schemas.openxmlformats.org/drawingml/2006/main" xmlns:r="http://schemas.openxmlformats.org/officeDocument/2006/relationships" xmlns:mc="http://schemas.openxmlformats.org/markup-compatibility/2006" xmlns:mv="urn:schemas-microsoft-com:mac:vml" xmlns:p="http://schemas.openxmlformats.org/presentationml/2006/main" xmlns:c="http://schemas.openxmlformats.org/drawingml/2006/chart" xmlns:dgm="http://schemas.openxmlformats.org/drawingml/2006/diagram" xmlns:o="urn:schemas-microsoft-com:office:office" xmlns:v="urn:schemas-microsoft-com:vml" xmlns:pvml="urn:schemas-microsoft-com:office:powerpoint" xmlns:com="http://schemas.openxmlformats.org/drawingml/2006/compatibility" xmlns:p14="http://schemas.microsoft.com/office/powerpoint/2010/main" xmlns:p15="http://schemas.microsoft.com/office/powerpoint/2012/main" xmlns:ahyp="http://schemas.microsoft.com/office/drawing/2018/hyperlinkcolor">
+  <p:cSld>
+    <p:spTree>
+      <p:nvGrpSpPr>
         <p:cNvPr id="114" name="Shape 114"/>
         <p:cNvGrpSpPr/>
         <p:nvPr/>
@@ -11076,7 +13280,7 @@
 </p:sld>
 </file>
 
-<file path=ppt/slides/slide8.xml><?xml version="1.0" encoding="utf-8"?>
+<file path=ppt/slides/slide9.xml><?xml version="1.0" encoding="utf-8"?>
 <p:sld xmlns:a="http://schemas.openxmlformats.org/drawingml/2006/main" xmlns:r="http://schemas.openxmlformats.org/officeDocument/2006/relationships" xmlns:mc="http://schemas.openxmlformats.org/markup-compatibility/2006" xmlns:mv="urn:schemas-microsoft-com:mac:vml" xmlns:p="http://schemas.openxmlformats.org/presentationml/2006/main" xmlns:c="http://schemas.openxmlformats.org/drawingml/2006/chart" xmlns:dgm="http://schemas.openxmlformats.org/drawingml/2006/diagram" xmlns:o="urn:schemas-microsoft-com:office:office" xmlns:v="urn:schemas-microsoft-com:vml" xmlns:pvml="urn:schemas-microsoft-com:office:powerpoint" xmlns:com="http://schemas.openxmlformats.org/drawingml/2006/compatibility" xmlns:p14="http://schemas.microsoft.com/office/powerpoint/2010/main" xmlns:p15="http://schemas.microsoft.com/office/powerpoint/2012/main" xmlns:ahyp="http://schemas.microsoft.com/office/drawing/2018/hyperlinkcolor">
   <p:cSld>
     <p:spTree>
@@ -12372,1063 +14576,6 @@
               <a:t>RESULTADOS ESPERADOS E CRONOGRAMA</a:t>
             </a:r>
             <a:endParaRPr b="1" sz="4700">
-              <a:solidFill>
-                <a:srgbClr val="33291F"/>
-              </a:solidFill>
-              <a:latin typeface="Cambria"/>
-              <a:ea typeface="Cambria"/>
-              <a:cs typeface="Cambria"/>
-              <a:sym typeface="Cambria"/>
-            </a:endParaRPr>
-          </a:p>
-        </p:txBody>
-      </p:sp>
-    </p:spTree>
-  </p:cSld>
-  <p:clrMapOvr>
-    <a:masterClrMapping/>
-  </p:clrMapOvr>
-</p:sld>
-</file>
-
-<file path=ppt/slides/slide9.xml><?xml version="1.0" encoding="utf-8"?>
-<p:sld xmlns:a="http://schemas.openxmlformats.org/drawingml/2006/main" xmlns:r="http://schemas.openxmlformats.org/officeDocument/2006/relationships" xmlns:mc="http://schemas.openxmlformats.org/markup-compatibility/2006" xmlns:mv="urn:schemas-microsoft-com:mac:vml" xmlns:p="http://schemas.openxmlformats.org/presentationml/2006/main" xmlns:c="http://schemas.openxmlformats.org/drawingml/2006/chart" xmlns:dgm="http://schemas.openxmlformats.org/drawingml/2006/diagram" xmlns:o="urn:schemas-microsoft-com:office:office" xmlns:v="urn:schemas-microsoft-com:vml" xmlns:pvml="urn:schemas-microsoft-com:office:powerpoint" xmlns:com="http://schemas.openxmlformats.org/drawingml/2006/compatibility" xmlns:p14="http://schemas.microsoft.com/office/powerpoint/2010/main" xmlns:p15="http://schemas.microsoft.com/office/powerpoint/2012/main" xmlns:ahyp="http://schemas.microsoft.com/office/drawing/2018/hyperlinkcolor">
-  <p:cSld>
-    <p:spTree>
-      <p:nvGrpSpPr>
-        <p:cNvPr id="160" name="Shape 160"/>
-        <p:cNvGrpSpPr/>
-        <p:nvPr/>
-      </p:nvGrpSpPr>
-      <p:grpSpPr>
-        <a:xfrm>
-          <a:off x="0" y="0"/>
-          <a:ext cx="0" cy="0"/>
-          <a:chOff x="0" y="0"/>
-          <a:chExt cx="0" cy="0"/>
-        </a:xfrm>
-      </p:grpSpPr>
-      <p:sp>
-        <p:nvSpPr>
-          <p:cNvPr id="161" name="Google Shape;161;p13"/>
-          <p:cNvSpPr/>
-          <p:nvPr/>
-        </p:nvSpPr>
-        <p:spPr>
-          <a:xfrm>
-            <a:off x="411475" y="1380351"/>
-            <a:ext cx="3722400" cy="3900600"/>
-          </a:xfrm>
-          <a:prstGeom prst="roundRect">
-            <a:avLst>
-              <a:gd fmla="val 4000" name="adj"/>
-            </a:avLst>
-          </a:prstGeom>
-          <a:solidFill>
-            <a:srgbClr val="FFFDF8"/>
-          </a:solidFill>
-          <a:ln cap="flat" cmpd="sng" w="9525">
-            <a:solidFill>
-              <a:srgbClr val="E6DCCB"/>
-            </a:solidFill>
-            <a:prstDash val="solid"/>
-            <a:round/>
-            <a:headEnd len="sm" w="sm" type="none"/>
-            <a:tailEnd len="sm" w="sm" type="none"/>
-          </a:ln>
-          <a:effectLst>
-            <a:outerShdw blurRad="127000" rotWithShape="0" algn="bl" dir="5400000" dist="25400">
-              <a:srgbClr val="33291F">
-                <a:alpha val="10196"/>
-              </a:srgbClr>
-            </a:outerShdw>
-          </a:effectLst>
-        </p:spPr>
-        <p:txBody>
-          <a:bodyPr anchorCtr="0" anchor="ctr" bIns="91425" lIns="91425" spcFirstLastPara="1" rIns="91425" wrap="square" tIns="91425">
-            <a:noAutofit/>
-          </a:bodyPr>
-          <a:lstStyle/>
-          <a:p>
-            <a:pPr indent="0" lvl="0" marL="0" rtl="0" algn="just">
-              <a:spcBef>
-                <a:spcPts val="0"/>
-              </a:spcBef>
-              <a:spcAft>
-                <a:spcPts val="0"/>
-              </a:spcAft>
-              <a:buNone/>
-            </a:pPr>
-            <a:r>
-              <a:t/>
-            </a:r>
-            <a:endParaRPr/>
-          </a:p>
-        </p:txBody>
-      </p:sp>
-      <p:sp>
-        <p:nvSpPr>
-          <p:cNvPr id="162" name="Google Shape;162;p13"/>
-          <p:cNvSpPr txBox="1"/>
-          <p:nvPr/>
-        </p:nvSpPr>
-        <p:spPr>
-          <a:xfrm>
-            <a:off x="576319" y="1534230"/>
-            <a:ext cx="2972700" cy="274200"/>
-          </a:xfrm>
-          <a:prstGeom prst="rect">
-            <a:avLst/>
-          </a:prstGeom>
-          <a:noFill/>
-          <a:ln>
-            <a:noFill/>
-          </a:ln>
-        </p:spPr>
-        <p:txBody>
-          <a:bodyPr anchorCtr="0" anchor="ctr" bIns="0" lIns="0" spcFirstLastPara="1" rIns="0" wrap="square" tIns="0">
-            <a:noAutofit/>
-          </a:bodyPr>
-          <a:lstStyle/>
-          <a:p>
-            <a:pPr indent="0" lvl="0" marL="0" marR="0" rtl="0" algn="just">
-              <a:spcBef>
-                <a:spcPts val="0"/>
-              </a:spcBef>
-              <a:spcAft>
-                <a:spcPts val="0"/>
-              </a:spcAft>
-              <a:buClr>
-                <a:srgbClr val="4A6B5B"/>
-              </a:buClr>
-              <a:buSzPts val="1250"/>
-              <a:buFont typeface="Calibri"/>
-              <a:buNone/>
-            </a:pPr>
-            <a:r>
-              <a:rPr b="1" i="0" lang="en-US" sz="2050" u="none" cap="none" strike="noStrike">
-                <a:solidFill>
-                  <a:srgbClr val="4A6B5B"/>
-                </a:solidFill>
-                <a:latin typeface="Calibri"/>
-                <a:ea typeface="Calibri"/>
-                <a:cs typeface="Calibri"/>
-                <a:sym typeface="Calibri"/>
-              </a:rPr>
-              <a:t>A FAVOR</a:t>
-            </a:r>
-            <a:endParaRPr b="0" i="0" sz="2050" u="none" cap="none" strike="noStrike">
-              <a:solidFill>
-                <a:schemeClr val="dk1"/>
-              </a:solidFill>
-              <a:latin typeface="Calibri"/>
-              <a:ea typeface="Calibri"/>
-              <a:cs typeface="Calibri"/>
-              <a:sym typeface="Calibri"/>
-            </a:endParaRPr>
-          </a:p>
-        </p:txBody>
-      </p:sp>
-      <p:sp>
-        <p:nvSpPr>
-          <p:cNvPr id="163" name="Google Shape;163;p13"/>
-          <p:cNvSpPr txBox="1"/>
-          <p:nvPr/>
-        </p:nvSpPr>
-        <p:spPr>
-          <a:xfrm>
-            <a:off x="558176" y="2088313"/>
-            <a:ext cx="3319800" cy="603600"/>
-          </a:xfrm>
-          <a:prstGeom prst="rect">
-            <a:avLst/>
-          </a:prstGeom>
-          <a:noFill/>
-          <a:ln>
-            <a:noFill/>
-          </a:ln>
-        </p:spPr>
-        <p:txBody>
-          <a:bodyPr anchorCtr="0" anchor="ctr" bIns="0" lIns="0" spcFirstLastPara="1" rIns="0" wrap="square" tIns="0">
-            <a:noAutofit/>
-          </a:bodyPr>
-          <a:lstStyle/>
-          <a:p>
-            <a:pPr indent="0" lvl="0" marL="0" marR="0" rtl="0" algn="just">
-              <a:lnSpc>
-                <a:spcPct val="131250"/>
-              </a:lnSpc>
-              <a:spcBef>
-                <a:spcPts val="0"/>
-              </a:spcBef>
-              <a:spcAft>
-                <a:spcPts val="0"/>
-              </a:spcAft>
-              <a:buClr>
-                <a:srgbClr val="33291F"/>
-              </a:buClr>
-              <a:buSzPts val="1600"/>
-              <a:buFont typeface="Cambria"/>
-              <a:buNone/>
-            </a:pPr>
-            <a:r>
-              <a:rPr b="1" i="0" lang="en-US" sz="3000" u="none" cap="none" strike="noStrike">
-                <a:solidFill>
-                  <a:srgbClr val="33291F"/>
-                </a:solidFill>
-                <a:latin typeface="Cambria"/>
-                <a:ea typeface="Cambria"/>
-                <a:cs typeface="Cambria"/>
-                <a:sym typeface="Cambria"/>
-              </a:rPr>
-              <a:t>A busca trivial não escala</a:t>
-            </a:r>
-            <a:endParaRPr b="0" i="0" sz="3000" u="none" cap="none" strike="noStrike">
-              <a:solidFill>
-                <a:schemeClr val="dk1"/>
-              </a:solidFill>
-              <a:latin typeface="Calibri"/>
-              <a:ea typeface="Calibri"/>
-              <a:cs typeface="Calibri"/>
-              <a:sym typeface="Calibri"/>
-            </a:endParaRPr>
-          </a:p>
-        </p:txBody>
-      </p:sp>
-      <p:sp>
-        <p:nvSpPr>
-          <p:cNvPr id="164" name="Google Shape;164;p13"/>
-          <p:cNvSpPr txBox="1"/>
-          <p:nvPr/>
-        </p:nvSpPr>
-        <p:spPr>
-          <a:xfrm>
-            <a:off x="563726" y="2984971"/>
-            <a:ext cx="3417900" cy="914400"/>
-          </a:xfrm>
-          <a:prstGeom prst="rect">
-            <a:avLst/>
-          </a:prstGeom>
-          <a:noFill/>
-          <a:ln>
-            <a:noFill/>
-          </a:ln>
-        </p:spPr>
-        <p:txBody>
-          <a:bodyPr anchorCtr="0" anchor="t" bIns="0" lIns="0" spcFirstLastPara="1" rIns="0" wrap="square" tIns="0">
-            <a:noAutofit/>
-          </a:bodyPr>
-          <a:lstStyle/>
-          <a:p>
-            <a:pPr indent="0" lvl="0" marL="0" marR="0" rtl="0" algn="just">
-              <a:lnSpc>
-                <a:spcPct val="126923"/>
-              </a:lnSpc>
-              <a:spcBef>
-                <a:spcPts val="0"/>
-              </a:spcBef>
-              <a:spcAft>
-                <a:spcPts val="0"/>
-              </a:spcAft>
-              <a:buClr>
-                <a:srgbClr val="5C4F41"/>
-              </a:buClr>
-              <a:buSzPts val="1300"/>
-              <a:buFont typeface="Calibri"/>
-              <a:buNone/>
-            </a:pPr>
-            <a:r>
-              <a:rPr b="0" i="0" lang="en-US" sz="2400" u="none" cap="none" strike="noStrike">
-                <a:solidFill>
-                  <a:srgbClr val="5C4F41"/>
-                </a:solidFill>
-                <a:latin typeface="Calibri"/>
-                <a:ea typeface="Calibri"/>
-                <a:cs typeface="Calibri"/>
-                <a:sym typeface="Calibri"/>
-              </a:rPr>
-              <a:t>Varrer o mesmo modelo declarativo sem heurística resolve até 5 ou 6 pacientes. Um turno real tem de 10 a 15.</a:t>
-            </a:r>
-            <a:endParaRPr b="0" i="0" sz="2400" u="none" cap="none" strike="noStrike">
-              <a:solidFill>
-                <a:schemeClr val="dk1"/>
-              </a:solidFill>
-              <a:latin typeface="Calibri"/>
-              <a:ea typeface="Calibri"/>
-              <a:cs typeface="Calibri"/>
-              <a:sym typeface="Calibri"/>
-            </a:endParaRPr>
-          </a:p>
-        </p:txBody>
-      </p:sp>
-      <p:sp>
-        <p:nvSpPr>
-          <p:cNvPr id="165" name="Google Shape;165;p13"/>
-          <p:cNvSpPr/>
-          <p:nvPr/>
-        </p:nvSpPr>
-        <p:spPr>
-          <a:xfrm>
-            <a:off x="4329450" y="1380400"/>
-            <a:ext cx="3514500" cy="3900600"/>
-          </a:xfrm>
-          <a:prstGeom prst="roundRect">
-            <a:avLst>
-              <a:gd fmla="val 4000" name="adj"/>
-            </a:avLst>
-          </a:prstGeom>
-          <a:solidFill>
-            <a:srgbClr val="FFFDF8"/>
-          </a:solidFill>
-          <a:ln cap="flat" cmpd="sng" w="9525">
-            <a:solidFill>
-              <a:srgbClr val="E6DCCB"/>
-            </a:solidFill>
-            <a:prstDash val="solid"/>
-            <a:round/>
-            <a:headEnd len="sm" w="sm" type="none"/>
-            <a:tailEnd len="sm" w="sm" type="none"/>
-          </a:ln>
-          <a:effectLst>
-            <a:outerShdw blurRad="127000" rotWithShape="0" algn="bl" dir="5400000" dist="25400">
-              <a:srgbClr val="33291F">
-                <a:alpha val="10196"/>
-              </a:srgbClr>
-            </a:outerShdw>
-          </a:effectLst>
-        </p:spPr>
-        <p:txBody>
-          <a:bodyPr anchorCtr="0" anchor="ctr" bIns="91425" lIns="91425" spcFirstLastPara="1" rIns="91425" wrap="square" tIns="91425">
-            <a:noAutofit/>
-          </a:bodyPr>
-          <a:lstStyle/>
-          <a:p>
-            <a:pPr indent="0" lvl="0" marL="0" rtl="0" algn="just">
-              <a:spcBef>
-                <a:spcPts val="0"/>
-              </a:spcBef>
-              <a:spcAft>
-                <a:spcPts val="0"/>
-              </a:spcAft>
-              <a:buNone/>
-            </a:pPr>
-            <a:r>
-              <a:t/>
-            </a:r>
-            <a:endParaRPr/>
-          </a:p>
-        </p:txBody>
-      </p:sp>
-      <p:sp>
-        <p:nvSpPr>
-          <p:cNvPr id="166" name="Google Shape;166;p13"/>
-          <p:cNvSpPr txBox="1"/>
-          <p:nvPr/>
-        </p:nvSpPr>
-        <p:spPr>
-          <a:xfrm>
-            <a:off x="4457565" y="1534168"/>
-            <a:ext cx="2972700" cy="274200"/>
-          </a:xfrm>
-          <a:prstGeom prst="rect">
-            <a:avLst/>
-          </a:prstGeom>
-          <a:noFill/>
-          <a:ln>
-            <a:noFill/>
-          </a:ln>
-        </p:spPr>
-        <p:txBody>
-          <a:bodyPr anchorCtr="0" anchor="ctr" bIns="0" lIns="0" spcFirstLastPara="1" rIns="0" wrap="square" tIns="0">
-            <a:noAutofit/>
-          </a:bodyPr>
-          <a:lstStyle/>
-          <a:p>
-            <a:pPr indent="0" lvl="0" marL="0" marR="0" rtl="0" algn="just">
-              <a:spcBef>
-                <a:spcPts val="0"/>
-              </a:spcBef>
-              <a:spcAft>
-                <a:spcPts val="0"/>
-              </a:spcAft>
-              <a:buClr>
-                <a:srgbClr val="4A6B5B"/>
-              </a:buClr>
-              <a:buSzPts val="1250"/>
-              <a:buFont typeface="Calibri"/>
-              <a:buNone/>
-            </a:pPr>
-            <a:r>
-              <a:rPr b="1" i="0" lang="en-US" sz="2050" u="none" cap="none" strike="noStrike">
-                <a:solidFill>
-                  <a:srgbClr val="4A6B5B"/>
-                </a:solidFill>
-                <a:latin typeface="Calibri"/>
-                <a:ea typeface="Calibri"/>
-                <a:cs typeface="Calibri"/>
-                <a:sym typeface="Calibri"/>
-              </a:rPr>
-              <a:t>A FAVOR</a:t>
-            </a:r>
-            <a:endParaRPr b="0" i="0" sz="2050" u="none" cap="none" strike="noStrike">
-              <a:solidFill>
-                <a:schemeClr val="dk1"/>
-              </a:solidFill>
-              <a:latin typeface="Calibri"/>
-              <a:ea typeface="Calibri"/>
-              <a:cs typeface="Calibri"/>
-              <a:sym typeface="Calibri"/>
-            </a:endParaRPr>
-          </a:p>
-        </p:txBody>
-      </p:sp>
-      <p:sp>
-        <p:nvSpPr>
-          <p:cNvPr id="167" name="Google Shape;167;p13"/>
-          <p:cNvSpPr txBox="1"/>
-          <p:nvPr/>
-        </p:nvSpPr>
-        <p:spPr>
-          <a:xfrm>
-            <a:off x="4460351" y="2011675"/>
-            <a:ext cx="3235500" cy="603600"/>
-          </a:xfrm>
-          <a:prstGeom prst="rect">
-            <a:avLst/>
-          </a:prstGeom>
-          <a:noFill/>
-          <a:ln>
-            <a:noFill/>
-          </a:ln>
-        </p:spPr>
-        <p:txBody>
-          <a:bodyPr anchorCtr="0" anchor="ctr" bIns="0" lIns="0" spcFirstLastPara="1" rIns="0" wrap="square" tIns="0">
-            <a:noAutofit/>
-          </a:bodyPr>
-          <a:lstStyle/>
-          <a:p>
-            <a:pPr indent="0" lvl="0" marL="0" marR="0" rtl="0" algn="just">
-              <a:lnSpc>
-                <a:spcPct val="131250"/>
-              </a:lnSpc>
-              <a:spcBef>
-                <a:spcPts val="0"/>
-              </a:spcBef>
-              <a:spcAft>
-                <a:spcPts val="0"/>
-              </a:spcAft>
-              <a:buClr>
-                <a:srgbClr val="33291F"/>
-              </a:buClr>
-              <a:buSzPts val="1600"/>
-              <a:buFont typeface="Cambria"/>
-              <a:buNone/>
-            </a:pPr>
-            <a:r>
-              <a:rPr b="1" i="0" lang="en-US" sz="3000" u="none" cap="none" strike="noStrike">
-                <a:solidFill>
-                  <a:srgbClr val="33291F"/>
-                </a:solidFill>
-                <a:latin typeface="Cambria"/>
-                <a:ea typeface="Cambria"/>
-                <a:cs typeface="Cambria"/>
-                <a:sym typeface="Cambria"/>
-              </a:rPr>
-              <a:t>O planejador está correto</a:t>
-            </a:r>
-            <a:endParaRPr b="0" i="0" sz="3000" u="none" cap="none" strike="noStrike">
-              <a:solidFill>
-                <a:schemeClr val="dk1"/>
-              </a:solidFill>
-              <a:latin typeface="Calibri"/>
-              <a:ea typeface="Calibri"/>
-              <a:cs typeface="Calibri"/>
-              <a:sym typeface="Calibri"/>
-            </a:endParaRPr>
-          </a:p>
-        </p:txBody>
-      </p:sp>
-      <p:sp>
-        <p:nvSpPr>
-          <p:cNvPr id="168" name="Google Shape;168;p13"/>
-          <p:cNvSpPr txBox="1"/>
-          <p:nvPr/>
-        </p:nvSpPr>
-        <p:spPr>
-          <a:xfrm>
-            <a:off x="4457575" y="3017525"/>
-            <a:ext cx="3235500" cy="914400"/>
-          </a:xfrm>
-          <a:prstGeom prst="rect">
-            <a:avLst/>
-          </a:prstGeom>
-          <a:noFill/>
-          <a:ln>
-            <a:noFill/>
-          </a:ln>
-        </p:spPr>
-        <p:txBody>
-          <a:bodyPr anchorCtr="0" anchor="t" bIns="0" lIns="0" spcFirstLastPara="1" rIns="0" wrap="square" tIns="0">
-            <a:noAutofit/>
-          </a:bodyPr>
-          <a:lstStyle/>
-          <a:p>
-            <a:pPr indent="0" lvl="0" marL="0" marR="0" rtl="0" algn="just">
-              <a:lnSpc>
-                <a:spcPct val="126923"/>
-              </a:lnSpc>
-              <a:spcBef>
-                <a:spcPts val="0"/>
-              </a:spcBef>
-              <a:spcAft>
-                <a:spcPts val="0"/>
-              </a:spcAft>
-              <a:buClr>
-                <a:srgbClr val="5C4F41"/>
-              </a:buClr>
-              <a:buSzPts val="1300"/>
-              <a:buFont typeface="Calibri"/>
-              <a:buNone/>
-            </a:pPr>
-            <a:r>
-              <a:rPr b="0" i="0" lang="en-US" sz="2200" u="none" cap="none" strike="noStrike">
-                <a:solidFill>
-                  <a:srgbClr val="5C4F41"/>
-                </a:solidFill>
-                <a:latin typeface="Calibri"/>
-                <a:ea typeface="Calibri"/>
-                <a:cs typeface="Calibri"/>
-                <a:sym typeface="Calibri"/>
-              </a:rPr>
-              <a:t>Um planejador de referência independente concordou sobre viabilidade e plano mínimo em todas as instâncias testadas.</a:t>
-            </a:r>
-            <a:endParaRPr b="0" i="0" sz="2200" u="none" cap="none" strike="noStrike">
-              <a:solidFill>
-                <a:schemeClr val="dk1"/>
-              </a:solidFill>
-              <a:latin typeface="Calibri"/>
-              <a:ea typeface="Calibri"/>
-              <a:cs typeface="Calibri"/>
-              <a:sym typeface="Calibri"/>
-            </a:endParaRPr>
-          </a:p>
-        </p:txBody>
-      </p:sp>
-      <p:sp>
-        <p:nvSpPr>
-          <p:cNvPr id="169" name="Google Shape;169;p13"/>
-          <p:cNvSpPr/>
-          <p:nvPr/>
-        </p:nvSpPr>
-        <p:spPr>
-          <a:xfrm>
-            <a:off x="8015400" y="1380301"/>
-            <a:ext cx="3490500" cy="3900600"/>
-          </a:xfrm>
-          <a:prstGeom prst="roundRect">
-            <a:avLst>
-              <a:gd fmla="val 4000" name="adj"/>
-            </a:avLst>
-          </a:prstGeom>
-          <a:solidFill>
-            <a:srgbClr val="F3DFD3"/>
-          </a:solidFill>
-          <a:ln cap="flat" cmpd="sng" w="9525">
-            <a:solidFill>
-              <a:srgbClr val="E6DCCB"/>
-            </a:solidFill>
-            <a:prstDash val="solid"/>
-            <a:round/>
-            <a:headEnd len="sm" w="sm" type="none"/>
-            <a:tailEnd len="sm" w="sm" type="none"/>
-          </a:ln>
-          <a:effectLst>
-            <a:outerShdw blurRad="127000" rotWithShape="0" algn="bl" dir="5400000" dist="25400">
-              <a:srgbClr val="33291F">
-                <a:alpha val="10196"/>
-              </a:srgbClr>
-            </a:outerShdw>
-          </a:effectLst>
-        </p:spPr>
-        <p:txBody>
-          <a:bodyPr anchorCtr="0" anchor="ctr" bIns="91425" lIns="91425" spcFirstLastPara="1" rIns="91425" wrap="square" tIns="91425">
-            <a:noAutofit/>
-          </a:bodyPr>
-          <a:lstStyle/>
-          <a:p>
-            <a:pPr indent="0" lvl="0" marL="0" rtl="0" algn="just">
-              <a:spcBef>
-                <a:spcPts val="0"/>
-              </a:spcBef>
-              <a:spcAft>
-                <a:spcPts val="0"/>
-              </a:spcAft>
-              <a:buNone/>
-            </a:pPr>
-            <a:r>
-              <a:t/>
-            </a:r>
-            <a:endParaRPr/>
-          </a:p>
-        </p:txBody>
-      </p:sp>
-      <p:sp>
-        <p:nvSpPr>
-          <p:cNvPr id="170" name="Google Shape;170;p13"/>
-          <p:cNvSpPr txBox="1"/>
-          <p:nvPr/>
-        </p:nvSpPr>
-        <p:spPr>
-          <a:xfrm>
-            <a:off x="8089262" y="1523316"/>
-            <a:ext cx="2972700" cy="274200"/>
-          </a:xfrm>
-          <a:prstGeom prst="rect">
-            <a:avLst/>
-          </a:prstGeom>
-          <a:noFill/>
-          <a:ln>
-            <a:noFill/>
-          </a:ln>
-        </p:spPr>
-        <p:txBody>
-          <a:bodyPr anchorCtr="0" anchor="ctr" bIns="0" lIns="0" spcFirstLastPara="1" rIns="0" wrap="square" tIns="0">
-            <a:noAutofit/>
-          </a:bodyPr>
-          <a:lstStyle/>
-          <a:p>
-            <a:pPr indent="0" lvl="0" marL="0" marR="0" rtl="0" algn="just">
-              <a:spcBef>
-                <a:spcPts val="0"/>
-              </a:spcBef>
-              <a:spcAft>
-                <a:spcPts val="0"/>
-              </a:spcAft>
-              <a:buClr>
-                <a:srgbClr val="B35C38"/>
-              </a:buClr>
-              <a:buSzPts val="1250"/>
-              <a:buFont typeface="Calibri"/>
-              <a:buNone/>
-            </a:pPr>
-            <a:r>
-              <a:rPr b="1" i="0" lang="en-US" sz="2050" u="none" cap="none" strike="noStrike">
-                <a:solidFill>
-                  <a:srgbClr val="B35C38"/>
-                </a:solidFill>
-                <a:latin typeface="Calibri"/>
-                <a:ea typeface="Calibri"/>
-                <a:cs typeface="Calibri"/>
-                <a:sym typeface="Calibri"/>
-              </a:rPr>
-              <a:t>CONTRA A HIPÓTESE</a:t>
-            </a:r>
-            <a:endParaRPr b="0" i="0" sz="2050" u="none" cap="none" strike="noStrike">
-              <a:solidFill>
-                <a:schemeClr val="dk1"/>
-              </a:solidFill>
-              <a:latin typeface="Calibri"/>
-              <a:ea typeface="Calibri"/>
-              <a:cs typeface="Calibri"/>
-              <a:sym typeface="Calibri"/>
-            </a:endParaRPr>
-          </a:p>
-        </p:txBody>
-      </p:sp>
-      <p:sp>
-        <p:nvSpPr>
-          <p:cNvPr id="171" name="Google Shape;171;p13"/>
-          <p:cNvSpPr txBox="1"/>
-          <p:nvPr/>
-        </p:nvSpPr>
-        <p:spPr>
-          <a:xfrm>
-            <a:off x="8089250" y="2011725"/>
-            <a:ext cx="3235500" cy="603600"/>
-          </a:xfrm>
-          <a:prstGeom prst="rect">
-            <a:avLst/>
-          </a:prstGeom>
-          <a:noFill/>
-          <a:ln>
-            <a:noFill/>
-          </a:ln>
-        </p:spPr>
-        <p:txBody>
-          <a:bodyPr anchorCtr="0" anchor="ctr" bIns="0" lIns="0" spcFirstLastPara="1" rIns="0" wrap="square" tIns="0">
-            <a:noAutofit/>
-          </a:bodyPr>
-          <a:lstStyle/>
-          <a:p>
-            <a:pPr indent="0" lvl="0" marL="0" marR="0" rtl="0" algn="just">
-              <a:lnSpc>
-                <a:spcPct val="131250"/>
-              </a:lnSpc>
-              <a:spcBef>
-                <a:spcPts val="0"/>
-              </a:spcBef>
-              <a:spcAft>
-                <a:spcPts val="0"/>
-              </a:spcAft>
-              <a:buClr>
-                <a:srgbClr val="33291F"/>
-              </a:buClr>
-              <a:buSzPts val="1600"/>
-              <a:buFont typeface="Cambria"/>
-              <a:buNone/>
-            </a:pPr>
-            <a:r>
-              <a:rPr b="1" i="0" lang="en-US" sz="3000" u="none" cap="none" strike="noStrike">
-                <a:solidFill>
-                  <a:srgbClr val="33291F"/>
-                </a:solidFill>
-                <a:latin typeface="Cambria"/>
-                <a:ea typeface="Cambria"/>
-                <a:cs typeface="Cambria"/>
-                <a:sym typeface="Cambria"/>
-              </a:rPr>
-              <a:t>A hipótese foi </a:t>
-            </a:r>
-            <a:r>
-              <a:rPr b="1" lang="en-US" sz="3000">
-                <a:solidFill>
-                  <a:srgbClr val="33291F"/>
-                </a:solidFill>
-                <a:latin typeface="Cambria"/>
-                <a:ea typeface="Cambria"/>
-                <a:cs typeface="Cambria"/>
-                <a:sym typeface="Cambria"/>
-              </a:rPr>
-              <a:t>“</a:t>
-            </a:r>
-            <a:r>
-              <a:rPr b="1" i="0" lang="en-US" sz="3000" u="none" cap="none" strike="noStrike">
-                <a:solidFill>
-                  <a:srgbClr val="33291F"/>
-                </a:solidFill>
-                <a:latin typeface="Cambria"/>
-                <a:ea typeface="Cambria"/>
-                <a:cs typeface="Cambria"/>
-                <a:sym typeface="Cambria"/>
-              </a:rPr>
-              <a:t>refutada</a:t>
-            </a:r>
-            <a:r>
-              <a:rPr b="1" lang="en-US" sz="3000">
-                <a:solidFill>
-                  <a:srgbClr val="33291F"/>
-                </a:solidFill>
-                <a:latin typeface="Cambria"/>
-                <a:ea typeface="Cambria"/>
-                <a:cs typeface="Cambria"/>
-                <a:sym typeface="Cambria"/>
-              </a:rPr>
-              <a:t>”</a:t>
-            </a:r>
-            <a:endParaRPr b="0" i="0" sz="3000" u="none" cap="none" strike="noStrike">
-              <a:solidFill>
-                <a:schemeClr val="dk1"/>
-              </a:solidFill>
-              <a:latin typeface="Calibri"/>
-              <a:ea typeface="Calibri"/>
-              <a:cs typeface="Calibri"/>
-              <a:sym typeface="Calibri"/>
-            </a:endParaRPr>
-          </a:p>
-        </p:txBody>
-      </p:sp>
-      <p:sp>
-        <p:nvSpPr>
-          <p:cNvPr id="172" name="Google Shape;172;p13"/>
-          <p:cNvSpPr txBox="1"/>
-          <p:nvPr/>
-        </p:nvSpPr>
-        <p:spPr>
-          <a:xfrm>
-            <a:off x="8089250" y="2984971"/>
-            <a:ext cx="3235500" cy="914400"/>
-          </a:xfrm>
-          <a:prstGeom prst="rect">
-            <a:avLst/>
-          </a:prstGeom>
-          <a:noFill/>
-          <a:ln>
-            <a:noFill/>
-          </a:ln>
-        </p:spPr>
-        <p:txBody>
-          <a:bodyPr anchorCtr="0" anchor="t" bIns="0" lIns="0" spcFirstLastPara="1" rIns="0" wrap="square" tIns="0">
-            <a:noAutofit/>
-          </a:bodyPr>
-          <a:lstStyle/>
-          <a:p>
-            <a:pPr indent="0" lvl="0" marL="0" marR="0" rtl="0" algn="just">
-              <a:lnSpc>
-                <a:spcPct val="126923"/>
-              </a:lnSpc>
-              <a:spcBef>
-                <a:spcPts val="0"/>
-              </a:spcBef>
-              <a:spcAft>
-                <a:spcPts val="0"/>
-              </a:spcAft>
-              <a:buClr>
-                <a:srgbClr val="5C4F41"/>
-              </a:buClr>
-              <a:buSzPts val="1300"/>
-              <a:buFont typeface="Calibri"/>
-              <a:buNone/>
-            </a:pPr>
-            <a:r>
-              <a:rPr b="0" i="0" lang="en-US" sz="2400" u="none" cap="none" strike="noStrike">
-                <a:solidFill>
-                  <a:srgbClr val="5C4F41"/>
-                </a:solidFill>
-                <a:latin typeface="Calibri"/>
-                <a:ea typeface="Calibri"/>
-                <a:cs typeface="Calibri"/>
-                <a:sym typeface="Calibri"/>
-              </a:rPr>
-              <a:t>Uma correção manual no executor procedural zera os falsos negativos. Ele não era incapaz: faltava-lhe a regra.</a:t>
-            </a:r>
-            <a:endParaRPr b="0" i="0" sz="2400" u="none" cap="none" strike="noStrike">
-              <a:solidFill>
-                <a:schemeClr val="dk1"/>
-              </a:solidFill>
-              <a:latin typeface="Calibri"/>
-              <a:ea typeface="Calibri"/>
-              <a:cs typeface="Calibri"/>
-              <a:sym typeface="Calibri"/>
-            </a:endParaRPr>
-          </a:p>
-        </p:txBody>
-      </p:sp>
-      <p:sp>
-        <p:nvSpPr>
-          <p:cNvPr id="173" name="Google Shape;173;p13"/>
-          <p:cNvSpPr/>
-          <p:nvPr/>
-        </p:nvSpPr>
-        <p:spPr>
-          <a:xfrm>
-            <a:off x="685950" y="5503383"/>
-            <a:ext cx="10820100" cy="713100"/>
-          </a:xfrm>
-          <a:prstGeom prst="roundRect">
-            <a:avLst>
-              <a:gd fmla="val 11538" name="adj"/>
-            </a:avLst>
-          </a:prstGeom>
-          <a:solidFill>
-            <a:srgbClr val="F3DFD3"/>
-          </a:solidFill>
-          <a:ln>
-            <a:noFill/>
-          </a:ln>
-        </p:spPr>
-        <p:txBody>
-          <a:bodyPr anchorCtr="0" anchor="ctr" bIns="91425" lIns="91425" spcFirstLastPara="1" rIns="91425" wrap="square" tIns="91425">
-            <a:noAutofit/>
-          </a:bodyPr>
-          <a:lstStyle/>
-          <a:p>
-            <a:pPr indent="0" lvl="0" marL="0" rtl="0" algn="just">
-              <a:spcBef>
-                <a:spcPts val="0"/>
-              </a:spcBef>
-              <a:spcAft>
-                <a:spcPts val="0"/>
-              </a:spcAft>
-              <a:buNone/>
-            </a:pPr>
-            <a:r>
-              <a:t/>
-            </a:r>
-            <a:endParaRPr/>
-          </a:p>
-        </p:txBody>
-      </p:sp>
-      <p:sp>
-        <p:nvSpPr>
-          <p:cNvPr id="174" name="Google Shape;174;p13"/>
-          <p:cNvSpPr txBox="1"/>
-          <p:nvPr/>
-        </p:nvSpPr>
-        <p:spPr>
-          <a:xfrm>
-            <a:off x="960270" y="5576535"/>
-            <a:ext cx="10271400" cy="567000"/>
-          </a:xfrm>
-          <a:prstGeom prst="rect">
-            <a:avLst/>
-          </a:prstGeom>
-          <a:noFill/>
-          <a:ln>
-            <a:noFill/>
-          </a:ln>
-        </p:spPr>
-        <p:txBody>
-          <a:bodyPr anchorCtr="0" anchor="ctr" bIns="0" lIns="0" spcFirstLastPara="1" rIns="0" wrap="square" tIns="0">
-            <a:noAutofit/>
-          </a:bodyPr>
-          <a:lstStyle/>
-          <a:p>
-            <a:pPr indent="0" lvl="0" marL="0" marR="0" rtl="0" algn="ctr">
-              <a:lnSpc>
-                <a:spcPct val="122580"/>
-              </a:lnSpc>
-              <a:spcBef>
-                <a:spcPts val="0"/>
-              </a:spcBef>
-              <a:spcAft>
-                <a:spcPts val="0"/>
-              </a:spcAft>
-              <a:buClr>
-                <a:srgbClr val="33291F"/>
-              </a:buClr>
-              <a:buSzPts val="1550"/>
-              <a:buFont typeface="Cambria"/>
-              <a:buNone/>
-            </a:pPr>
-            <a:r>
-              <a:rPr b="0" i="1" lang="en-US" sz="2400" u="none" cap="none" strike="noStrike">
-                <a:solidFill>
-                  <a:srgbClr val="33291F"/>
-                </a:solidFill>
-                <a:latin typeface="Cambria"/>
-                <a:ea typeface="Cambria"/>
-                <a:cs typeface="Cambria"/>
-                <a:sym typeface="Cambria"/>
-              </a:rPr>
-              <a:t>O caminho 1 de erro, previsto no slide da hipótese, foi o que se materializou.</a:t>
-            </a:r>
-            <a:endParaRPr b="0" i="0" sz="2400" u="none" cap="none" strike="noStrike">
-              <a:solidFill>
-                <a:schemeClr val="dk1"/>
-              </a:solidFill>
-              <a:latin typeface="Calibri"/>
-              <a:ea typeface="Calibri"/>
-              <a:cs typeface="Calibri"/>
-              <a:sym typeface="Calibri"/>
-            </a:endParaRPr>
-          </a:p>
-        </p:txBody>
-      </p:sp>
-      <p:sp>
-        <p:nvSpPr>
-          <p:cNvPr id="175" name="Google Shape;175;p13"/>
-          <p:cNvSpPr txBox="1"/>
-          <p:nvPr>
-            <p:ph idx="4294967295" type="sldNum"/>
-          </p:nvPr>
-        </p:nvSpPr>
-        <p:spPr>
-          <a:xfrm>
-            <a:off x="11384280" y="6327648"/>
-            <a:ext cx="365760" cy="274320"/>
-          </a:xfrm>
-          <a:prstGeom prst="rect">
-            <a:avLst/>
-          </a:prstGeom>
-          <a:noFill/>
-          <a:ln>
-            <a:noFill/>
-          </a:ln>
-        </p:spPr>
-        <p:txBody>
-          <a:bodyPr anchorCtr="0" anchor="t" bIns="45700" lIns="91425" spcFirstLastPara="1" rIns="91425" wrap="square" tIns="45700">
-            <a:noAutofit/>
-          </a:bodyPr>
-          <a:lstStyle/>
-          <a:p>
-            <a:pPr indent="0" lvl="0" marL="0" marR="0" rtl="0" algn="r">
-              <a:spcBef>
-                <a:spcPts val="0"/>
-              </a:spcBef>
-              <a:spcAft>
-                <a:spcPts val="0"/>
-              </a:spcAft>
-              <a:buNone/>
-            </a:pPr>
-            <a:fld id="{00000000-1234-1234-1234-123412341234}" type="slidenum">
-              <a:rPr b="0" i="0" lang="en-US" sz="1000" u="none" cap="none" strike="noStrike">
-                <a:solidFill>
-                  <a:srgbClr val="8A7A67"/>
-                </a:solidFill>
-                <a:latin typeface="Calibri"/>
-                <a:ea typeface="Calibri"/>
-                <a:cs typeface="Calibri"/>
-                <a:sym typeface="Calibri"/>
-              </a:rPr>
-              <a:t>‹#›</a:t>
-            </a:fld>
-            <a:endParaRPr b="0" i="0" sz="1000" u="none" cap="none" strike="noStrike">
-              <a:solidFill>
-                <a:srgbClr val="8A7A67"/>
-              </a:solidFill>
-              <a:latin typeface="Calibri"/>
-              <a:ea typeface="Calibri"/>
-              <a:cs typeface="Calibri"/>
-              <a:sym typeface="Calibri"/>
-            </a:endParaRPr>
-          </a:p>
-        </p:txBody>
-      </p:sp>
-      <p:sp>
-        <p:nvSpPr>
-          <p:cNvPr id="176" name="Google Shape;176;p13"/>
-          <p:cNvSpPr txBox="1"/>
-          <p:nvPr/>
-        </p:nvSpPr>
-        <p:spPr>
-          <a:xfrm>
-            <a:off x="411475" y="304883"/>
-            <a:ext cx="10820100" cy="868800"/>
-          </a:xfrm>
-          <a:prstGeom prst="rect">
-            <a:avLst/>
-          </a:prstGeom>
-          <a:noFill/>
-          <a:ln>
-            <a:noFill/>
-          </a:ln>
-        </p:spPr>
-        <p:txBody>
-          <a:bodyPr anchorCtr="0" anchor="t" bIns="0" lIns="0" spcFirstLastPara="1" rIns="0" wrap="square" tIns="0">
-            <a:noAutofit/>
-          </a:bodyPr>
-          <a:lstStyle/>
-          <a:p>
-            <a:pPr indent="0" lvl="0" marL="0" marR="0" rtl="0" algn="just">
-              <a:lnSpc>
-                <a:spcPct val="111764"/>
-              </a:lnSpc>
-              <a:spcBef>
-                <a:spcPts val="0"/>
-              </a:spcBef>
-              <a:spcAft>
-                <a:spcPts val="0"/>
-              </a:spcAft>
-              <a:buClr>
-                <a:srgbClr val="33291F"/>
-              </a:buClr>
-              <a:buSzPts val="3400"/>
-              <a:buFont typeface="Cambria"/>
-              <a:buNone/>
-            </a:pPr>
-            <a:r>
-              <a:rPr b="1" lang="en-US" sz="4800">
-                <a:solidFill>
-                  <a:srgbClr val="33291F"/>
-                </a:solidFill>
-                <a:latin typeface="Cambria"/>
-                <a:ea typeface="Cambria"/>
-                <a:cs typeface="Cambria"/>
-                <a:sym typeface="Cambria"/>
-              </a:rPr>
-              <a:t>RESULTADOS JÁ OBTIDOS</a:t>
-            </a:r>
-            <a:endParaRPr b="1" sz="4800">
               <a:solidFill>
                 <a:srgbClr val="33291F"/>
               </a:solidFill>

</xml_diff>